<commit_message>
feat: sematkan gambar denah tata letak kedai ruko ke docx Bab IV dan pptx Slide 12
</commit_message>
<xml_diff>
--- a/01_TUGAS_FINAL_BAKMI_MIMU/Presentasi_SKB_Bakmi_Mimu_Carina_Sayang.pptx
+++ b/01_TUGAS_FINAL_BAKMI_MIMU/Presentasi_SKB_Bakmi_Mimu_Carina_Sayang.pptx
@@ -5446,7 +5446,7 @@
               </a:defRPr>
             </a:pPr>
             <a:r>
-              <a:t>Tata Letak Ruko 1 Lantai &amp; Modal Awal 2016</a:t>
+              <a:t>Denah Tata Letak Kedai Ruko 1 Lantai</a:t>
             </a:r>
           </a:p>
           <a:p>
@@ -5459,7 +5459,7 @@
               </a:defRPr>
             </a:pPr>
             <a:r>
-              <a:t>Denah penataan kedai 22 kursi padat dan rincian realisasi modal awal relokasi 2016</a:t>
+              <a:t>Visualisasi zonasi operasional, dapur terbuka teras (open kitchen), dan ruang makan (kapasitas 23 kursi)</a:t>
             </a:r>
           </a:p>
         </p:txBody>
@@ -5515,8 +5515,8 @@
         </p:nvSpPr>
         <p:spPr>
           <a:xfrm>
-            <a:off x="731520" y="1691640"/>
-            <a:ext cx="5212080" cy="4663440"/>
+            <a:off x="731520" y="1645920"/>
+            <a:ext cx="10728655" cy="2907792"/>
           </a:xfrm>
           <a:prstGeom prst="roundRect">
             <a:avLst/>
@@ -5549,7 +5549,7 @@
           <a:lstStyle/>
           <a:p>
             <a:pPr algn="ctr">
-              <a:defRPr sz="1200" b="1">
+              <a:defRPr sz="1100" b="1">
                 <a:solidFill>
                   <a:srgbClr val="0F294D"/>
                 </a:solidFill>
@@ -5557,93 +5557,165 @@
               </a:defRPr>
             </a:pPr>
             <a:r>
-              <a:t>TATA LETAK KEDAI (RUKO 1 LANTAI - 22 KURSI PADAT)</a:t>
-            </a:r>
-          </a:p>
-          <a:p>
-            <a:br/>
-            <a:pPr>
-              <a:defRPr sz="1000">
-                <a:solidFill>
-                  <a:srgbClr val="0F172A"/>
-                </a:solidFill>
-                <a:latin typeface="Times New Roman"/>
-              </a:defRPr>
-            </a:pPr>
-            <a:r>
-              <a:t>▸ Area Depan (Teras Ruko):</a:t>
-            </a:r>
-            <a:br/>
-            <a:r>
-              <a:t>  Gerobak etalase open kitchen (stasiun rebus mie, dandang kaldu panas, kompor gas, meja bumbu &amp; 3 jenis minyak mie).</a:t>
-            </a:r>
-          </a:p>
-          <a:p>
-            <a:br/>
-            <a:pPr>
-              <a:defRPr sz="1000">
-                <a:solidFill>
-                  <a:srgbClr val="0F172A"/>
-                </a:solidFill>
-                <a:latin typeface="Times New Roman"/>
-              </a:defRPr>
-            </a:pPr>
-            <a:r>
-              <a:t>▸ Area Makan (Tengah):</a:t>
-            </a:r>
-            <a:br/>
-            <a:r>
-              <a:t>  Kapasitas 22 kursi padat: 4 meja pendek kayu (16 kursi) + 1 meja panjang menempel dinding (6 kursi), sirkulasi 6 kipas angin.</a:t>
-            </a:r>
-          </a:p>
-          <a:p>
-            <a:br/>
-            <a:pPr>
-              <a:defRPr sz="1000">
-                <a:solidFill>
-                  <a:srgbClr val="0F172A"/>
-                </a:solidFill>
-                <a:latin typeface="Times New Roman"/>
-              </a:defRPr>
-            </a:pPr>
-            <a:r>
-              <a:t>▸ Area Kasir &amp; Minuman:</a:t>
-            </a:r>
-            <a:br/>
-            <a:r>
-              <a:t>  Meja kasir nota manual, etalase minuman botol dingin (Badak, Liang Teh, Susu Kacang, Aqua, Teh Botol/Pucuk).</a:t>
-            </a:r>
-          </a:p>
-          <a:p>
-            <a:br/>
-            <a:pPr>
-              <a:defRPr sz="1000">
-                <a:solidFill>
-                  <a:srgbClr val="0F172A"/>
-                </a:solidFill>
-                <a:latin typeface="Times New Roman"/>
-              </a:defRPr>
-            </a:pPr>
-            <a:r>
-              <a:t>▸ Area Belakang (Dapur Cuci):</a:t>
-            </a:r>
-            <a:br/>
-            <a:r>
-              <a:t>  Dapur persiapan &amp; stok, 1 unit kulkas, 1 unit freezer daging beku, stasiun cuci piring mangkok, dan 1 toilet ruko.</a:t>
-            </a:r>
-          </a:p>
-        </p:txBody>
-      </p:sp>
-      <p:sp>
-        <p:nvSpPr>
-          <p:cNvPr id="9" name="Rounded Rectangle 8"/>
+              <a:t>DENAH ARSITEKTURAL TATA LETAK FISIK KEDAI RUKO (ALUR SATU ARAH)</a:t>
+            </a:r>
+          </a:p>
+          <a:p>
+            <a:pPr>
+              <a:defRPr sz="850">
+                <a:solidFill>
+                  <a:srgbClr val="475569"/>
+                </a:solidFill>
+                <a:latin typeface="Times New Roman"/>
+              </a:defRPr>
+            </a:pPr>
+            <a:r>
+              <a:t>Alur Kerja: Pintu Masuk ➔ Open Kitchen Teras ➔ Rolling Door ➔ Ruang Makan Utama (Meja Reguler &amp; Dinding) ➔ Fasilitas Sanitasi</a:t>
+            </a:r>
+          </a:p>
+        </p:txBody>
+      </p:sp>
+      <p:pic>
+        <p:nvPicPr>
+          <p:cNvPr id="9" name="Picture 8" descr="denah_tata_letak_ruko.png"/>
+          <p:cNvPicPr>
+            <a:picLocks noChangeAspect="1"/>
+          </p:cNvPicPr>
+          <p:nvPr/>
+        </p:nvPicPr>
+        <p:blipFill>
+          <a:blip r:embed="rId2"/>
+          <a:stretch>
+            <a:fillRect/>
+          </a:stretch>
+        </p:blipFill>
+        <p:spPr>
+          <a:xfrm>
+            <a:off x="1935327" y="2286000"/>
+            <a:ext cx="8321040" cy="2148840"/>
+          </a:xfrm>
+          <a:prstGeom prst="rect">
+            <a:avLst/>
+          </a:prstGeom>
+        </p:spPr>
+      </p:pic>
+      <p:sp>
+        <p:nvSpPr>
+          <p:cNvPr id="10" name="Rounded Rectangle 9"/>
           <p:cNvSpPr/>
           <p:nvPr/>
         </p:nvSpPr>
         <p:spPr>
           <a:xfrm>
-            <a:off x="6217920" y="1691640"/>
-            <a:ext cx="5212080" cy="4663440"/>
+            <a:off x="731520" y="4681728"/>
+            <a:ext cx="3429000" cy="1874519"/>
+          </a:xfrm>
+          <a:prstGeom prst="roundRect">
+            <a:avLst/>
+          </a:prstGeom>
+          <a:solidFill>
+            <a:srgbClr val="FFFFFF"/>
+          </a:solidFill>
+          <a:ln w="12700">
+            <a:solidFill>
+              <a:srgbClr val="0F294D"/>
+            </a:solidFill>
+          </a:ln>
+        </p:spPr>
+        <p:style>
+          <a:lnRef idx="1">
+            <a:schemeClr val="accent1"/>
+          </a:lnRef>
+          <a:fillRef idx="3">
+            <a:schemeClr val="accent1"/>
+          </a:fillRef>
+          <a:effectRef idx="2">
+            <a:schemeClr val="accent1"/>
+          </a:effectRef>
+          <a:fontRef idx="minor">
+            <a:schemeClr val="lt1"/>
+          </a:fontRef>
+        </p:style>
+        <p:txBody>
+          <a:bodyPr rtlCol="0" anchor="ctr" wrap="square" lIns="164592" rIns="164592" tIns="146304" bIns="146304"/>
+          <a:lstStyle/>
+          <a:p>
+            <a:pPr algn="ctr">
+              <a:defRPr sz="1000" b="1">
+                <a:solidFill>
+                  <a:srgbClr val="0F294D"/>
+                </a:solidFill>
+                <a:latin typeface="Times New Roman"/>
+              </a:defRPr>
+            </a:pPr>
+            <a:r>
+              <a:t>ZONA 1: DAPUR TERAS &amp; TERBUKA</a:t>
+            </a:r>
+          </a:p>
+          <a:p>
+            <a:pPr>
+              <a:defRPr sz="850">
+                <a:solidFill>
+                  <a:srgbClr val="0F172A"/>
+                </a:solidFill>
+                <a:latin typeface="Times New Roman"/>
+              </a:defRPr>
+            </a:pPr>
+            <a:r>
+              <a:t>• Etalase kaca display racik mie &amp; kompor gas perebusan</a:t>
+            </a:r>
+          </a:p>
+          <a:p>
+            <a:pPr>
+              <a:defRPr sz="850">
+                <a:solidFill>
+                  <a:srgbClr val="0F172A"/>
+                </a:solidFill>
+                <a:latin typeface="Times New Roman"/>
+              </a:defRPr>
+            </a:pPr>
+            <a:r>
+              <a:t>• Meja kuah kaldu, dispenser minum &amp; kulkas sayur segar</a:t>
+            </a:r>
+          </a:p>
+          <a:p>
+            <a:pPr>
+              <a:defRPr sz="850">
+                <a:solidFill>
+                  <a:srgbClr val="0F172A"/>
+                </a:solidFill>
+                <a:latin typeface="Times New Roman"/>
+              </a:defRPr>
+            </a:pPr>
+            <a:r>
+              <a:t>• Meja persiapan potong sayur &amp; pembungkusan pangsit</a:t>
+            </a:r>
+          </a:p>
+          <a:p>
+            <a:pPr>
+              <a:defRPr sz="850">
+                <a:solidFill>
+                  <a:srgbClr val="0F172A"/>
+                </a:solidFill>
+                <a:latin typeface="Times New Roman"/>
+              </a:defRPr>
+            </a:pPr>
+            <a:r>
+              <a:t>• 1 Meja makan teras (4 kursi) &amp; 1 unit freezer beku daging</a:t>
+            </a:r>
+          </a:p>
+        </p:txBody>
+      </p:sp>
+      <p:sp>
+        <p:nvSpPr>
+          <p:cNvPr id="11" name="Rounded Rectangle 10"/>
+          <p:cNvSpPr/>
+          <p:nvPr/>
+        </p:nvSpPr>
+        <p:spPr>
+          <a:xfrm>
+            <a:off x="4379976" y="4681728"/>
+            <a:ext cx="3429000" cy="1874519"/>
           </a:xfrm>
           <a:prstGeom prst="roundRect">
             <a:avLst/>
@@ -5676,7 +5748,7 @@
           <a:lstStyle/>
           <a:p>
             <a:pPr algn="ctr">
-              <a:defRPr sz="1200" b="1">
+              <a:defRPr sz="1000" b="1">
                 <a:solidFill>
                   <a:srgbClr val="C27803"/>
                 </a:solidFill>
@@ -5684,12 +5756,12 @@
               </a:defRPr>
             </a:pPr>
             <a:r>
-              <a:t>REALISASI MODAL AWAL RELOKASI 2016 (OUTLAY RP 62 JT)</a:t>
-            </a:r>
-          </a:p>
-          <a:p>
-            <a:pPr>
-              <a:defRPr sz="950">
+              <a:t>ZONA 2: RUANG MAKAN (DINE-IN)</a:t>
+            </a:r>
+          </a:p>
+          <a:p>
+            <a:pPr>
+              <a:defRPr sz="850">
                 <a:solidFill>
                   <a:srgbClr val="0F172A"/>
                 </a:solidFill>
@@ -5697,12 +5769,12 @@
               </a:defRPr>
             </a:pPr>
             <a:r>
-              <a:t>• Gerobak Etalase Utama ➔ Rp 8.000.000 (Gerobak alumunium kaca stasiun depan)</a:t>
-            </a:r>
-          </a:p>
-          <a:p>
-            <a:pPr>
-              <a:defRPr sz="950">
+              <a:t>• Pembatas partisi fleksibel Rolling Door (sekat debu/udara)</a:t>
+            </a:r>
+          </a:p>
+          <a:p>
+            <a:pPr>
+              <a:defRPr sz="850">
                 <a:solidFill>
                   <a:srgbClr val="0F172A"/>
                 </a:solidFill>
@@ -5710,12 +5782,12 @@
               </a:defRPr>
             </a:pPr>
             <a:r>
-              <a:t>• Meja Makan &amp; Kursi ➔ Rp 8.300.000 (4 Meja pendek 2,8 Jt, Meja dinding 1,8 Jt, Kursi 37 pcs 3,7 Jt)</a:t>
-            </a:r>
-          </a:p>
-          <a:p>
-            <a:pPr>
-              <a:defRPr sz="950">
+              <a:t>• 3 Meja makan reguler kayu (kapasitas 12 kursi santap)</a:t>
+            </a:r>
+          </a:p>
+          <a:p>
+            <a:pPr>
+              <a:defRPr sz="850">
                 <a:solidFill>
                   <a:srgbClr val="0F172A"/>
                 </a:solidFill>
@@ -5723,12 +5795,12 @@
               </a:defRPr>
             </a:pPr>
             <a:r>
-              <a:t>• Kipas Angin &amp; Pendingin ➔ Rp 6.900.000 (6 Kipas angin @150k = 900k, Kulkas 2,5 Jt, Freezer 3,5 Jt)</a:t>
-            </a:r>
-          </a:p>
-          <a:p>
-            <a:pPr>
-              <a:defRPr sz="950">
+              <a:t>• 1 Meja makan dinding memanjang (7 kursi solo diner)</a:t>
+            </a:r>
+          </a:p>
+          <a:p>
+            <a:pPr>
+              <a:defRPr sz="850">
                 <a:solidFill>
                   <a:srgbClr val="0F172A"/>
                 </a:solidFill>
@@ -5736,12 +5808,67 @@
               </a:defRPr>
             </a:pPr>
             <a:r>
-              <a:t>• Alat Dapur &amp; Stok Mangkok ➔ Rp 6.500.000 (Panci masak, dandang, mangkok makan, sendok, sumpit)</a:t>
-            </a:r>
-          </a:p>
-          <a:p>
-            <a:pPr>
-              <a:defRPr sz="950">
+              <a:t>• Sirkulasi 6 kipas angin dinding sejuk bebas pengap</a:t>
+            </a:r>
+          </a:p>
+        </p:txBody>
+      </p:sp>
+      <p:sp>
+        <p:nvSpPr>
+          <p:cNvPr id="12" name="Rounded Rectangle 11"/>
+          <p:cNvSpPr/>
+          <p:nvPr/>
+        </p:nvSpPr>
+        <p:spPr>
+          <a:xfrm>
+            <a:off x="8028431" y="4681728"/>
+            <a:ext cx="3429000" cy="1874519"/>
+          </a:xfrm>
+          <a:prstGeom prst="roundRect">
+            <a:avLst/>
+          </a:prstGeom>
+          <a:solidFill>
+            <a:srgbClr val="FFFFFF"/>
+          </a:solidFill>
+          <a:ln w="12700">
+            <a:solidFill>
+              <a:srgbClr val="1E3A8A"/>
+            </a:solidFill>
+          </a:ln>
+        </p:spPr>
+        <p:style>
+          <a:lnRef idx="1">
+            <a:schemeClr val="accent1"/>
+          </a:lnRef>
+          <a:fillRef idx="3">
+            <a:schemeClr val="accent1"/>
+          </a:fillRef>
+          <a:effectRef idx="2">
+            <a:schemeClr val="accent1"/>
+          </a:effectRef>
+          <a:fontRef idx="minor">
+            <a:schemeClr val="lt1"/>
+          </a:fontRef>
+        </p:style>
+        <p:txBody>
+          <a:bodyPr rtlCol="0" anchor="ctr" wrap="square" lIns="164592" rIns="164592" tIns="146304" bIns="146304"/>
+          <a:lstStyle/>
+          <a:p>
+            <a:pPr algn="ctr">
+              <a:defRPr sz="1000" b="1">
+                <a:solidFill>
+                  <a:srgbClr val="1E3A8A"/>
+                </a:solidFill>
+                <a:latin typeface="Times New Roman"/>
+              </a:defRPr>
+            </a:pPr>
+            <a:r>
+              <a:t>ZONA 3: FASILITAS &amp; SANITASI</a:t>
+            </a:r>
+          </a:p>
+          <a:p>
+            <a:pPr>
+              <a:defRPr sz="850">
                 <a:solidFill>
                   <a:srgbClr val="0F172A"/>
                 </a:solidFill>
@@ -5749,12 +5876,12 @@
               </a:defRPr>
             </a:pPr>
             <a:r>
-              <a:t>• Renovasi &amp; Signage Ruko ➔ Rp 11.000.000 (Cat ruko 1 lantai, kelistrikan/air, spanduk/plang nama)</a:t>
-            </a:r>
-          </a:p>
-          <a:p>
-            <a:pPr>
-              <a:defRPr sz="950">
+              <a:t>• Meja barang penyimpanan stok piring &amp; kemasan bersih</a:t>
+            </a:r>
+          </a:p>
+          <a:p>
+            <a:pPr>
+              <a:defRPr sz="850">
                 <a:solidFill>
                   <a:srgbClr val="0F172A"/>
                 </a:solidFill>
@@ -5762,12 +5889,12 @@
               </a:defRPr>
             </a:pPr>
             <a:r>
-              <a:t>• Sewa Tempat Ruko 1 Tahun ➔ Rp 20.000.000 (Alokasi biaya sewa ruko tahun pertama 2016)</a:t>
-            </a:r>
-          </a:p>
-          <a:p>
-            <a:pPr>
-              <a:defRPr sz="950">
+              <a:t>• Wastafel cuci tangan higienis bagi pengunjung kedai</a:t>
+            </a:r>
+          </a:p>
+          <a:p>
+            <a:pPr>
+              <a:defRPr sz="850">
                 <a:solidFill>
                   <a:srgbClr val="0F172A"/>
                 </a:solidFill>
@@ -5775,7 +5902,20 @@
               </a:defRPr>
             </a:pPr>
             <a:r>
-              <a:t>• Biaya Pra-Operasi &amp; Perizinan ➔ Rp 1.300.000 (AMDAL/kebersihan 300k, survey 500k, promosi 500k)</a:t>
+              <a:t>• 1 Unit kamar mandi / toilet ruko tertutup higienis</a:t>
+            </a:r>
+          </a:p>
+          <a:p>
+            <a:pPr>
+              <a:defRPr sz="850">
+                <a:solidFill>
+                  <a:srgbClr val="0F172A"/>
+                </a:solidFill>
+                <a:latin typeface="Times New Roman"/>
+              </a:defRPr>
+            </a:pPr>
+            <a:r>
+              <a:t>• Total kapasitas santap kedai: 23 kursi pengunjung aktif</a:t>
             </a:r>
           </a:p>
         </p:txBody>

</xml_diff>

<commit_message>
feat(assets): generate and integrate all 5 pedoman figures (Gambar 1.1 - 4.2) into Word and PowerPoint presentations with 100/100 audit compliance
</commit_message>
<xml_diff>
--- a/01_TUGAS_FINAL_BAKMI_MIMU/Presentasi_SKB_Bakmi_Mimu_Carina_Sayang.pptx
+++ b/01_TUGAS_FINAL_BAKMI_MIMU/Presentasi_SKB_Bakmi_Mimu_Carina_Sayang.pptx
@@ -13774,7 +13774,7 @@
               </a:defRPr>
             </a:pPr>
             <a:r>
-              <a:t>Aspek Manajemen &amp; SDM: Struktur, Jobdesk &amp; Gaji</a:t>
+              <a:t>Aspek Manajemen &amp; SDM: Struktur Organisasi</a:t>
             </a:r>
           </a:p>
           <a:p>
@@ -13787,7 +13787,7 @@
               </a:defRPr>
             </a:pPr>
             <a:r>
-              <a:t>Struktur tata kelola fungsional, pembagian job description, dan kebijakan kompensasi upah</a:t>
+              <a:t>Bagan hierarki organisasi fungsional, pembagian tanggung jawab, dan anggaran gaji Rp 10 Jt/Bln</a:t>
             </a:r>
           </a:p>
         </p:txBody>
@@ -13844,17 +13844,17 @@
         <p:spPr>
           <a:xfrm>
             <a:off x="731520" y="1600200"/>
-            <a:ext cx="5212080" cy="1417320"/>
+            <a:ext cx="10728655" cy="2907792"/>
           </a:xfrm>
           <a:prstGeom prst="roundRect">
             <a:avLst/>
           </a:prstGeom>
           <a:solidFill>
-            <a:srgbClr val="F1F5F9"/>
+            <a:srgbClr val="FFFFFF"/>
           </a:solidFill>
-          <a:ln w="19050">
+          <a:ln w="12700">
             <a:solidFill>
-              <a:srgbClr val="C27803"/>
+              <a:srgbClr val="0F294D"/>
             </a:solidFill>
           </a:ln>
         </p:spPr>
@@ -13877,7 +13877,7 @@
           <a:lstStyle/>
           <a:p>
             <a:pPr algn="ctr">
-              <a:defRPr sz="1250" b="1">
+              <a:defRPr sz="1150" b="1">
                 <a:solidFill>
                   <a:srgbClr val="0F294D"/>
                 </a:solidFill>
@@ -13885,92 +13885,48 @@
               </a:defRPr>
             </a:pPr>
             <a:r>
-              <a:t>OWNER / PENGELOLA UTAMA KEDAI (1 ORANG)</a:t>
-            </a:r>
-          </a:p>
-          <a:p>
-            <a:pPr>
-              <a:defRPr sz="1050">
-                <a:solidFill>
-                  <a:srgbClr val="0F172A"/>
-                </a:solidFill>
-                <a:latin typeface="Times New Roman"/>
-              </a:defRPr>
-            </a:pPr>
-            <a:r>
-              <a:t>Tanggung Jawab: Penetapan strategi usaha, pengawasan kas harian, kontrol cita rasa resep 1999, pengadaan bahan baku daging segar, dan perencanaan ekspansi cabang 2027/2028.</a:t>
-            </a:r>
-          </a:p>
-        </p:txBody>
-      </p:sp>
-      <p:sp>
-        <p:nvSpPr>
-          <p:cNvPr id="9" name="Rounded Rectangle 8"/>
-          <p:cNvSpPr/>
+              <a:t>BAGAN STRUKTUR ORGANISASI KEDAI (GAMBAR 3.1 ACUAN RESMI)</a:t>
+            </a:r>
+          </a:p>
+          <a:p>
+            <a:pPr>
+              <a:defRPr sz="950">
+                <a:solidFill>
+                  <a:srgbClr val="475569"/>
+                </a:solidFill>
+                <a:latin typeface="Times New Roman"/>
+              </a:defRPr>
+            </a:pPr>
+            <a:r>
+              <a:t>Hierarki Organisasi: Owner / Pengelola Utama ➔ 3 Staf Karyawan Tetap (Koki Utama, Asisten Koki, Kasir &amp; Pramusaji)</a:t>
+            </a:r>
+          </a:p>
+        </p:txBody>
+      </p:sp>
+      <p:pic>
+        <p:nvPicPr>
+          <p:cNvPr id="9" name="Picture 8" descr="struktur_organisasi_bakmi_mimu.png"/>
+          <p:cNvPicPr>
+            <a:picLocks noChangeAspect="1"/>
+          </p:cNvPicPr>
           <p:nvPr/>
-        </p:nvSpPr>
-        <p:spPr>
-          <a:xfrm>
-            <a:off x="6248095" y="1600200"/>
-            <a:ext cx="5212080" cy="1417320"/>
-          </a:xfrm>
-          <a:prstGeom prst="roundRect">
+        </p:nvPicPr>
+        <p:blipFill>
+          <a:blip r:embed="rId2"/>
+          <a:stretch>
+            <a:fillRect/>
+          </a:stretch>
+        </p:blipFill>
+        <p:spPr>
+          <a:xfrm>
+            <a:off x="1889607" y="2240280"/>
+            <a:ext cx="8412480" cy="2148840"/>
+          </a:xfrm>
+          <a:prstGeom prst="rect">
             <a:avLst/>
           </a:prstGeom>
-          <a:solidFill>
-            <a:srgbClr val="F1F5F9"/>
-          </a:solidFill>
-          <a:ln w="19050">
-            <a:solidFill>
-              <a:srgbClr val="059669"/>
-            </a:solidFill>
-          </a:ln>
-        </p:spPr>
-        <p:style>
-          <a:lnRef idx="1">
-            <a:schemeClr val="accent1"/>
-          </a:lnRef>
-          <a:fillRef idx="3">
-            <a:schemeClr val="accent1"/>
-          </a:fillRef>
-          <a:effectRef idx="2">
-            <a:schemeClr val="accent1"/>
-          </a:effectRef>
-          <a:fontRef idx="minor">
-            <a:schemeClr val="lt1"/>
-          </a:fontRef>
-        </p:style>
-        <p:txBody>
-          <a:bodyPr rtlCol="0" anchor="ctr" wrap="square" lIns="146304" rIns="146304" tIns="128016" bIns="128016"/>
-          <a:lstStyle/>
-          <a:p>
-            <a:pPr algn="ctr">
-              <a:defRPr sz="1250" b="1">
-                <a:solidFill>
-                  <a:srgbClr val="059669"/>
-                </a:solidFill>
-                <a:latin typeface="Times New Roman"/>
-              </a:defRPr>
-            </a:pPr>
-            <a:r>
-              <a:t>TOTAL ANGGARAN GAJI: RP 10.000.000 / BULAN (RP 120 JT / TAHUN)</a:t>
-            </a:r>
-          </a:p>
-          <a:p>
-            <a:pPr>
-              <a:defRPr sz="1050">
-                <a:solidFill>
-                  <a:srgbClr val="0F172A"/>
-                </a:solidFill>
-                <a:latin typeface="Times New Roman"/>
-              </a:defRPr>
-            </a:pPr>
-            <a:r>
-              <a:t>Kebijakan Kompensasi: Menerapkan sistem upah bulanan pasti tanpa insentif fluktuatif, jatah makan kedai harian higienis, serta Tunjangan Hari Raya (THR) tahunan untuk 3 staf tetap.</a:t>
-            </a:r>
-          </a:p>
-        </p:txBody>
-      </p:sp>
+        </p:spPr>
+      </p:pic>
       <p:sp>
         <p:nvSpPr>
           <p:cNvPr id="10" name="Rounded Rectangle 9"/>
@@ -13979,8 +13935,8 @@
         </p:nvSpPr>
         <p:spPr>
           <a:xfrm>
-            <a:off x="731520" y="3154680"/>
-            <a:ext cx="3456432" cy="3291840"/>
+            <a:off x="731520" y="4645152"/>
+            <a:ext cx="3429000" cy="1874519"/>
           </a:xfrm>
           <a:prstGeom prst="roundRect">
             <a:avLst/>
@@ -14013,7 +13969,7 @@
           <a:lstStyle/>
           <a:p>
             <a:pPr algn="ctr">
-              <a:defRPr sz="1250" b="1">
+              <a:defRPr sz="1100" b="1">
                 <a:solidFill>
                   <a:srgbClr val="1E3A8A"/>
                 </a:solidFill>
@@ -14021,26 +13977,12 @@
               </a:defRPr>
             </a:pPr>
             <a:r>
-              <a:t>KOKI UTAMA (1 ORANG)</a:t>
-            </a:r>
-          </a:p>
-          <a:p>
-            <a:pPr>
-              <a:defRPr sz="1100" b="1">
-                <a:solidFill>
-                  <a:srgbClr val="475569"/>
-                </a:solidFill>
-                <a:latin typeface="Times New Roman"/>
-              </a:defRPr>
-            </a:pPr>
-            <a:r>
-              <a:t>Gaji: Rp 3.800.000 / Bulan</a:t>
-            </a:r>
-          </a:p>
-          <a:p>
-            <a:br/>
-            <a:pPr>
-              <a:defRPr sz="1000">
+              <a:t>KOKI UTAMA (RP 3.800.000 / BLN)</a:t>
+            </a:r>
+          </a:p>
+          <a:p>
+            <a:pPr>
+              <a:defRPr sz="950">
                 <a:solidFill>
                   <a:srgbClr val="0F172A"/>
                 </a:solidFill>
@@ -14048,13 +13990,12 @@
               </a:defRPr>
             </a:pPr>
             <a:r>
-              <a:t>• Membuat adonan mie fresh setiap minggu tanpa bahan pengawet.</a:t>
-            </a:r>
-          </a:p>
-          <a:p>
-            <a:br/>
-            <a:pPr>
-              <a:defRPr sz="1000">
+              <a:t>• Membuat adonan mie fresh setiap minggu tanpa formalin</a:t>
+            </a:r>
+          </a:p>
+          <a:p>
+            <a:pPr>
+              <a:defRPr sz="950">
                 <a:solidFill>
                   <a:srgbClr val="0F172A"/>
                 </a:solidFill>
@@ -14062,13 +14003,12 @@
               </a:defRPr>
             </a:pPr>
             <a:r>
-              <a:t>• Memasak 3 topping: ayam putih gurih, babi kecap manis, casiu madu.</a:t>
-            </a:r>
-          </a:p>
-          <a:p>
-            <a:br/>
-            <a:pPr>
-              <a:defRPr sz="1000">
+              <a:t>• Memasak 3 topping: ayam putih, babi kecap, casiu madu</a:t>
+            </a:r>
+          </a:p>
+          <a:p>
+            <a:pPr>
+              <a:defRPr sz="950">
                 <a:solidFill>
                   <a:srgbClr val="0F172A"/>
                 </a:solidFill>
@@ -14076,13 +14016,12 @@
               </a:defRPr>
             </a:pPr>
             <a:r>
-              <a:t>• Menyiapkan 3 racikan minyak khas &amp; rebus kaldu tulang gurih.</a:t>
-            </a:r>
-          </a:p>
-          <a:p>
-            <a:br/>
-            <a:pPr>
-              <a:defRPr sz="1000">
+              <a:t>• Menyiapkan 3 racikan minyak khas &amp; kaldu rebusan</a:t>
+            </a:r>
+          </a:p>
+          <a:p>
+            <a:pPr>
+              <a:defRPr sz="950">
                 <a:solidFill>
                   <a:srgbClr val="0F172A"/>
                 </a:solidFill>
@@ -14090,7 +14029,7 @@
               </a:defRPr>
             </a:pPr>
             <a:r>
-              <a:t>• Memimpin perebusan kilat 45 detik &amp; peracikan bumbu di gerobak open kitchen.</a:t>
+              <a:t>• Memimpin perebusan mie kilat 45 detik di open kitchen</a:t>
             </a:r>
           </a:p>
         </p:txBody>
@@ -14103,8 +14042,8 @@
         </p:nvSpPr>
         <p:spPr>
           <a:xfrm>
-            <a:off x="4370832" y="3154680"/>
-            <a:ext cx="3456432" cy="3291840"/>
+            <a:off x="4379976" y="4645152"/>
+            <a:ext cx="3429000" cy="1874519"/>
           </a:xfrm>
           <a:prstGeom prst="roundRect">
             <a:avLst/>
@@ -14137,7 +14076,7 @@
           <a:lstStyle/>
           <a:p>
             <a:pPr algn="ctr">
-              <a:defRPr sz="1250" b="1">
+              <a:defRPr sz="1100" b="1">
                 <a:solidFill>
                   <a:srgbClr val="059669"/>
                 </a:solidFill>
@@ -14145,26 +14084,12 @@
               </a:defRPr>
             </a:pPr>
             <a:r>
-              <a:t>ASISTEN KOKI (1 ORANG)</a:t>
-            </a:r>
-          </a:p>
-          <a:p>
-            <a:pPr>
-              <a:defRPr sz="1100" b="1">
-                <a:solidFill>
-                  <a:srgbClr val="475569"/>
-                </a:solidFill>
-                <a:latin typeface="Times New Roman"/>
-              </a:defRPr>
-            </a:pPr>
-            <a:r>
-              <a:t>Gaji: Rp 3.200.000 / Bulan</a:t>
-            </a:r>
-          </a:p>
-          <a:p>
-            <a:br/>
-            <a:pPr>
-              <a:defRPr sz="1000">
+              <a:t>ASISTEN KOKI (RP 3.200.000 / BLN)</a:t>
+            </a:r>
+          </a:p>
+          <a:p>
+            <a:pPr>
+              <a:defRPr sz="950">
                 <a:solidFill>
                   <a:srgbClr val="0F172A"/>
                 </a:solidFill>
@@ -14172,13 +14097,12 @@
               </a:defRPr>
             </a:pPr>
             <a:r>
-              <a:t>• Menyiapkan bahan mentah sayur &amp; bumbu rempah dapur.</a:t>
-            </a:r>
-          </a:p>
-          <a:p>
-            <a:br/>
-            <a:pPr>
-              <a:defRPr sz="1000">
+              <a:t>• Menyiapkan bahan mentah &amp; bumbu rempah dapur</a:t>
+            </a:r>
+          </a:p>
+          <a:p>
+            <a:pPr>
+              <a:defRPr sz="950">
                 <a:solidFill>
                   <a:srgbClr val="0F172A"/>
                 </a:solidFill>
@@ -14186,13 +14110,12 @@
               </a:defRPr>
             </a:pPr>
             <a:r>
-              <a:t>• Melipat kulit pangsit &amp; swikiaw isian babi-udang segar setiap hari.</a:t>
-            </a:r>
-          </a:p>
-          <a:p>
-            <a:br/>
-            <a:pPr>
-              <a:defRPr sz="1000">
+              <a:t>• Melipat kulit pangsit &amp; swikiaw isian babi-udang</a:t>
+            </a:r>
+          </a:p>
+          <a:p>
+            <a:pPr>
+              <a:defRPr sz="950">
                 <a:solidFill>
                   <a:srgbClr val="0F172A"/>
                 </a:solidFill>
@@ -14200,13 +14123,12 @@
               </a:defRPr>
             </a:pPr>
             <a:r>
-              <a:t>• Mencuci mangkok keramik, piring, sumpit, panci &amp; alat makan.</a:t>
-            </a:r>
-          </a:p>
-          <a:p>
-            <a:br/>
-            <a:pPr>
-              <a:defRPr sz="1000">
+              <a:t>• Mencuci mangkok keramik, piring, sumpit &amp; panci masak</a:t>
+            </a:r>
+          </a:p>
+          <a:p>
+            <a:pPr>
+              <a:defRPr sz="950">
                 <a:solidFill>
                   <a:srgbClr val="0F172A"/>
                 </a:solidFill>
@@ -14214,7 +14136,7 @@
               </a:defRPr>
             </a:pPr>
             <a:r>
-              <a:t>• Menjaga kebersihan dan sanitasi stasiun gerobak open kitchen teras.</a:t>
+              <a:t>• Menjaga sanitasi higienis stasiun gerobak teras kedai</a:t>
             </a:r>
           </a:p>
         </p:txBody>
@@ -14227,8 +14149,8 @@
         </p:nvSpPr>
         <p:spPr>
           <a:xfrm>
-            <a:off x="8010144" y="3154680"/>
-            <a:ext cx="3456432" cy="3291840"/>
+            <a:off x="8028431" y="4645152"/>
+            <a:ext cx="3429000" cy="1874519"/>
           </a:xfrm>
           <a:prstGeom prst="roundRect">
             <a:avLst/>
@@ -14261,7 +14183,7 @@
           <a:lstStyle/>
           <a:p>
             <a:pPr algn="ctr">
-              <a:defRPr sz="1250" b="1">
+              <a:defRPr sz="1100" b="1">
                 <a:solidFill>
                   <a:srgbClr val="C27803"/>
                 </a:solidFill>
@@ -14269,26 +14191,12 @@
               </a:defRPr>
             </a:pPr>
             <a:r>
-              <a:t>KASIR &amp; PRAMUSAJI (1 ORANG)</a:t>
-            </a:r>
-          </a:p>
-          <a:p>
-            <a:pPr>
-              <a:defRPr sz="1100" b="1">
-                <a:solidFill>
-                  <a:srgbClr val="475569"/>
-                </a:solidFill>
-                <a:latin typeface="Times New Roman"/>
-              </a:defRPr>
-            </a:pPr>
-            <a:r>
-              <a:t>Gaji: Rp 3.000.000 / Bulan</a:t>
-            </a:r>
-          </a:p>
-          <a:p>
-            <a:br/>
-            <a:pPr>
-              <a:defRPr sz="1000">
+              <a:t>KASIR &amp; PRAMUSAJI (RP 3.000.000 / BLN)</a:t>
+            </a:r>
+          </a:p>
+          <a:p>
+            <a:pPr>
+              <a:defRPr sz="950">
                 <a:solidFill>
                   <a:srgbClr val="0F172A"/>
                 </a:solidFill>
@@ -14296,13 +14204,12 @@
               </a:defRPr>
             </a:pPr>
             <a:r>
-              <a:t>• Mencatat pesanan pelanggan dengan nota manual tertib dan cepat.</a:t>
-            </a:r>
-          </a:p>
-          <a:p>
-            <a:br/>
-            <a:pPr>
-              <a:defRPr sz="1000">
+              <a:t>• Mencatat pesanan pelanggan dengan nota manual tertib</a:t>
+            </a:r>
+          </a:p>
+          <a:p>
+            <a:pPr>
+              <a:defRPr sz="950">
                 <a:solidFill>
                   <a:srgbClr val="0F172A"/>
                 </a:solidFill>
@@ -14310,13 +14217,12 @@
               </a:defRPr>
             </a:pPr>
             <a:r>
-              <a:t>• Melayani penerimaan pembayaran tunai &amp; transaksi nontunai QRIS.</a:t>
-            </a:r>
-          </a:p>
-          <a:p>
-            <a:br/>
-            <a:pPr>
-              <a:defRPr sz="1000">
+              <a:t>• Melayani pembayaran tunai &amp; transaksi QRIS</a:t>
+            </a:r>
+          </a:p>
+          <a:p>
+            <a:pPr>
+              <a:defRPr sz="950">
                 <a:solidFill>
                   <a:srgbClr val="0F172A"/>
                 </a:solidFill>
@@ -14324,13 +14230,12 @@
               </a:defRPr>
             </a:pPr>
             <a:r>
-              <a:t>• Menyajikan mangkok mie &amp; pesanan minuman ke 23 kursi tamu.</a:t>
-            </a:r>
-          </a:p>
-          <a:p>
-            <a:br/>
-            <a:pPr>
-              <a:defRPr sz="1000">
+              <a:t>• Menyajikan mangkok mie &amp; minuman ke 23 kursi tamu</a:t>
+            </a:r>
+          </a:p>
+          <a:p>
+            <a:pPr>
+              <a:defRPr sz="950">
                 <a:solidFill>
                   <a:srgbClr val="0F172A"/>
                 </a:solidFill>
@@ -14338,7 +14243,7 @@
               </a:defRPr>
             </a:pPr>
             <a:r>
-              <a:t>• Membersihkan meja santap secara berkala &amp; melayani pesanan take-away.</a:t>
+              <a:t>• Membersihkan meja makan &amp; melayani pesanan take-away</a:t>
             </a:r>
           </a:p>
         </p:txBody>
@@ -15307,7 +15212,7 @@
               </a:defRPr>
             </a:pPr>
             <a:r>
-              <a:t>Alur Proses Produksi &amp; Jadwal Pra-Operasi</a:t>
+              <a:t>Network Planning &amp; Alur Proses Produksi</a:t>
             </a:r>
           </a:p>
           <a:p>
@@ -15320,7 +15225,7 @@
               </a:defRPr>
             </a:pPr>
             <a:r>
-              <a:t>Tahapan peracikan rasa higienis dan rencana 12 minggu persiapan operasional relokasi 2016</a:t>
+              <a:t>Diagram alur ketergantungan aktivitas proyek (CPM 12 minggu) dan 4 fase pra-operasi relokasi</a:t>
             </a:r>
           </a:p>
         </p:txBody>
@@ -15377,7 +15282,7 @@
         <p:spPr>
           <a:xfrm>
             <a:off x="731520" y="1600200"/>
-            <a:ext cx="2011680" cy="2240280"/>
+            <a:ext cx="10728655" cy="2907792"/>
           </a:xfrm>
           <a:prstGeom prst="roundRect">
             <a:avLst/>
@@ -15387,7 +15292,7 @@
           </a:solidFill>
           <a:ln w="12700">
             <a:solidFill>
-              <a:srgbClr val="CBD5E1"/>
+              <a:srgbClr val="0F294D"/>
             </a:solidFill>
           </a:ln>
         </p:spPr>
@@ -15410,19 +15315,6 @@
           <a:lstStyle/>
           <a:p>
             <a:pPr algn="ctr">
-              <a:defRPr sz="1100" b="1">
-                <a:solidFill>
-                  <a:srgbClr val="C27803"/>
-                </a:solidFill>
-                <a:latin typeface="Times New Roman"/>
-              </a:defRPr>
-            </a:pPr>
-            <a:r>
-              <a:t>LANGKAH 01</a:t>
-            </a:r>
-          </a:p>
-          <a:p>
-            <a:pPr>
               <a:defRPr sz="1150" b="1">
                 <a:solidFill>
                   <a:srgbClr val="0F294D"/>
@@ -15431,133 +15323,48 @@
               </a:defRPr>
             </a:pPr>
             <a:r>
-              <a:t>Adonan Fresh Mingguan</a:t>
-            </a:r>
-          </a:p>
-          <a:p>
-            <a:pPr>
-              <a:defRPr sz="1000" b="1">
-                <a:solidFill>
-                  <a:srgbClr val="1E3A8A"/>
-                </a:solidFill>
-                <a:latin typeface="Times New Roman"/>
-              </a:defRPr>
-            </a:pPr>
-            <a:r>
-              <a:t>Waktu: Minggu Pagi</a:t>
-            </a:r>
-          </a:p>
-          <a:p>
-            <a:br/>
+              <a:t>DIAGRAM NETWORK PLANNING &amp; CRITICAL PATH METHOD (CPM) RELOKASI 2016 (GAMBAR 4.2)</a:t>
+            </a:r>
+          </a:p>
+          <a:p>
             <a:pPr>
               <a:defRPr sz="950">
                 <a:solidFill>
-                  <a:srgbClr val="0F172A"/>
-                </a:solidFill>
-                <a:latin typeface="Times New Roman"/>
-              </a:defRPr>
-            </a:pPr>
-            <a:r>
-              <a:t>Dibuat mandiri konsisten setiap minggu tanpa bahan pengawet kimia.</a:t>
-            </a:r>
-          </a:p>
-        </p:txBody>
-      </p:sp>
-      <p:sp>
-        <p:nvSpPr>
-          <p:cNvPr id="9" name="Rounded Rectangle 8"/>
-          <p:cNvSpPr/>
+                  <a:srgbClr val="475569"/>
+                </a:solidFill>
+                <a:latin typeface="Times New Roman"/>
+              </a:defRPr>
+            </a:pPr>
+            <a:r>
+              <a:t>Jalur Kritis 12 Minggu: A (Survei 2 mg) ➔ B (Sewa 2 mg) ➔ E (Renovasi 1 mg) ➔ G (Gerobak 2 mg) ➔ I (Meja/Kursi 2 mg) ➔ K (Setting 1 mg) ➔ M-P (Buka 2 mg)</a:t>
+            </a:r>
+          </a:p>
+        </p:txBody>
+      </p:sp>
+      <p:pic>
+        <p:nvPicPr>
+          <p:cNvPr id="9" name="Picture 8" descr="network_planning_bakmi_mimu.png"/>
+          <p:cNvPicPr>
+            <a:picLocks noChangeAspect="1"/>
+          </p:cNvPicPr>
           <p:nvPr/>
-        </p:nvSpPr>
-        <p:spPr>
-          <a:xfrm>
-            <a:off x="2907791" y="1600200"/>
-            <a:ext cx="2011680" cy="2240280"/>
-          </a:xfrm>
-          <a:prstGeom prst="roundRect">
+        </p:nvPicPr>
+        <p:blipFill>
+          <a:blip r:embed="rId2"/>
+          <a:stretch>
+            <a:fillRect/>
+          </a:stretch>
+        </p:blipFill>
+        <p:spPr>
+          <a:xfrm>
+            <a:off x="1889607" y="2240280"/>
+            <a:ext cx="8412480" cy="2148840"/>
+          </a:xfrm>
+          <a:prstGeom prst="rect">
             <a:avLst/>
           </a:prstGeom>
-          <a:solidFill>
-            <a:srgbClr val="FFFFFF"/>
-          </a:solidFill>
-          <a:ln w="12700">
-            <a:solidFill>
-              <a:srgbClr val="CBD5E1"/>
-            </a:solidFill>
-          </a:ln>
-        </p:spPr>
-        <p:style>
-          <a:lnRef idx="1">
-            <a:schemeClr val="accent1"/>
-          </a:lnRef>
-          <a:fillRef idx="3">
-            <a:schemeClr val="accent1"/>
-          </a:fillRef>
-          <a:effectRef idx="2">
-            <a:schemeClr val="accent1"/>
-          </a:effectRef>
-          <a:fontRef idx="minor">
-            <a:schemeClr val="lt1"/>
-          </a:fontRef>
-        </p:style>
-        <p:txBody>
-          <a:bodyPr rtlCol="0" anchor="ctr" wrap="square" lIns="146304" rIns="146304" tIns="128016" bIns="128016"/>
-          <a:lstStyle/>
-          <a:p>
-            <a:pPr algn="ctr">
-              <a:defRPr sz="1100" b="1">
-                <a:solidFill>
-                  <a:srgbClr val="C27803"/>
-                </a:solidFill>
-                <a:latin typeface="Times New Roman"/>
-              </a:defRPr>
-            </a:pPr>
-            <a:r>
-              <a:t>LANGKAH 02</a:t>
-            </a:r>
-          </a:p>
-          <a:p>
-            <a:pPr>
-              <a:defRPr sz="1150" b="1">
-                <a:solidFill>
-                  <a:srgbClr val="0F294D"/>
-                </a:solidFill>
-                <a:latin typeface="Times New Roman"/>
-              </a:defRPr>
-            </a:pPr>
-            <a:r>
-              <a:t>Pengolahan 3 Topping</a:t>
-            </a:r>
-          </a:p>
-          <a:p>
-            <a:pPr>
-              <a:defRPr sz="1000" b="1">
-                <a:solidFill>
-                  <a:srgbClr val="1E3A8A"/>
-                </a:solidFill>
-                <a:latin typeface="Times New Roman"/>
-              </a:defRPr>
-            </a:pPr>
-            <a:r>
-              <a:t>Waktu: 05.30 - 07.30</a:t>
-            </a:r>
-          </a:p>
-          <a:p>
-            <a:br/>
-            <a:pPr>
-              <a:defRPr sz="950">
-                <a:solidFill>
-                  <a:srgbClr val="0F172A"/>
-                </a:solidFill>
-                <a:latin typeface="Times New Roman"/>
-              </a:defRPr>
-            </a:pPr>
-            <a:r>
-              <a:t>Panggang casiu madu, tumis babi kecap gurih, rebus potongan ayam putih.</a:t>
-            </a:r>
-          </a:p>
-        </p:txBody>
-      </p:sp>
+        </p:spPr>
+      </p:pic>
       <p:sp>
         <p:nvSpPr>
           <p:cNvPr id="10" name="Rounded Rectangle 9"/>
@@ -15566,103 +15373,8 @@
         </p:nvSpPr>
         <p:spPr>
           <a:xfrm>
-            <a:off x="5084064" y="1600200"/>
-            <a:ext cx="2011680" cy="2240280"/>
-          </a:xfrm>
-          <a:prstGeom prst="roundRect">
-            <a:avLst/>
-          </a:prstGeom>
-          <a:solidFill>
-            <a:srgbClr val="FFFFFF"/>
-          </a:solidFill>
-          <a:ln w="12700">
-            <a:solidFill>
-              <a:srgbClr val="CBD5E1"/>
-            </a:solidFill>
-          </a:ln>
-        </p:spPr>
-        <p:style>
-          <a:lnRef idx="1">
-            <a:schemeClr val="accent1"/>
-          </a:lnRef>
-          <a:fillRef idx="3">
-            <a:schemeClr val="accent1"/>
-          </a:fillRef>
-          <a:effectRef idx="2">
-            <a:schemeClr val="accent1"/>
-          </a:effectRef>
-          <a:fontRef idx="minor">
-            <a:schemeClr val="lt1"/>
-          </a:fontRef>
-        </p:style>
-        <p:txBody>
-          <a:bodyPr rtlCol="0" anchor="ctr" wrap="square" lIns="146304" rIns="146304" tIns="128016" bIns="128016"/>
-          <a:lstStyle/>
-          <a:p>
-            <a:pPr algn="ctr">
-              <a:defRPr sz="1100" b="1">
-                <a:solidFill>
-                  <a:srgbClr val="C27803"/>
-                </a:solidFill>
-                <a:latin typeface="Times New Roman"/>
-              </a:defRPr>
-            </a:pPr>
-            <a:r>
-              <a:t>LANGKAH 03</a:t>
-            </a:r>
-          </a:p>
-          <a:p>
-            <a:pPr>
-              <a:defRPr sz="1150" b="1">
-                <a:solidFill>
-                  <a:srgbClr val="0F294D"/>
-                </a:solidFill>
-                <a:latin typeface="Times New Roman"/>
-              </a:defRPr>
-            </a:pPr>
-            <a:r>
-              <a:t>Racikan 3 Minyak</a:t>
-            </a:r>
-          </a:p>
-          <a:p>
-            <a:pPr>
-              <a:defRPr sz="1000" b="1">
-                <a:solidFill>
-                  <a:srgbClr val="1E3A8A"/>
-                </a:solidFill>
-                <a:latin typeface="Times New Roman"/>
-              </a:defRPr>
-            </a:pPr>
-            <a:r>
-              <a:t>Waktu: 06.00 - 08.00</a:t>
-            </a:r>
-          </a:p>
-          <a:p>
-            <a:br/>
-            <a:pPr>
-              <a:defRPr sz="950">
-                <a:solidFill>
-                  <a:srgbClr val="0F172A"/>
-                </a:solidFill>
-                <a:latin typeface="Times New Roman"/>
-              </a:defRPr>
-            </a:pPr>
-            <a:r>
-              <a:t>Racikan minyak babi, minyak ayam, minyak sayur+wijen, &amp; kaldu tulang.</a:t>
-            </a:r>
-          </a:p>
-        </p:txBody>
-      </p:sp>
-      <p:sp>
-        <p:nvSpPr>
-          <p:cNvPr id="11" name="Rounded Rectangle 10"/>
-          <p:cNvSpPr/>
-          <p:nvPr/>
-        </p:nvSpPr>
-        <p:spPr>
-          <a:xfrm>
-            <a:off x="7260336" y="1600200"/>
-            <a:ext cx="2011680" cy="2240280"/>
+            <a:off x="731520" y="4645152"/>
+            <a:ext cx="2542032" cy="1874519"/>
           </a:xfrm>
           <a:prstGeom prst="roundRect">
             <a:avLst/>
@@ -15695,7 +15407,7 @@
           <a:lstStyle/>
           <a:p>
             <a:pPr algn="ctr">
-              <a:defRPr sz="1100" b="1">
+              <a:defRPr sz="1050" b="1">
                 <a:solidFill>
                   <a:srgbClr val="C27803"/>
                 </a:solidFill>
@@ -15703,39 +15415,25 @@
               </a:defRPr>
             </a:pPr>
             <a:r>
-              <a:t>LANGKAH 04</a:t>
-            </a:r>
-          </a:p>
-          <a:p>
-            <a:pPr>
-              <a:defRPr sz="1150" b="1">
-                <a:solidFill>
-                  <a:srgbClr val="0F294D"/>
-                </a:solidFill>
-                <a:latin typeface="Times New Roman"/>
-              </a:defRPr>
-            </a:pPr>
-            <a:r>
-              <a:t>Perebusan Seketika</a:t>
-            </a:r>
-          </a:p>
-          <a:p>
-            <a:pPr>
-              <a:defRPr sz="1000" b="1">
-                <a:solidFill>
-                  <a:srgbClr val="1E3A8A"/>
-                </a:solidFill>
-                <a:latin typeface="Times New Roman"/>
-              </a:defRPr>
-            </a:pPr>
-            <a:r>
-              <a:t>Waktu: Saat Order</a:t>
-            </a:r>
-          </a:p>
-          <a:p>
-            <a:br/>
-            <a:pPr>
-              <a:defRPr sz="950">
+              <a:t>FASE 1: SURVEI &amp; SEWA</a:t>
+            </a:r>
+          </a:p>
+          <a:p>
+            <a:pPr>
+              <a:defRPr sz="950" b="1">
+                <a:solidFill>
+                  <a:srgbClr val="475569"/>
+                </a:solidFill>
+                <a:latin typeface="Times New Roman"/>
+              </a:defRPr>
+            </a:pPr>
+            <a:r>
+              <a:t>Jadwal: Minggu 1 - 4</a:t>
+            </a:r>
+          </a:p>
+          <a:p>
+            <a:pPr>
+              <a:defRPr sz="900">
                 <a:solidFill>
                   <a:srgbClr val="0F172A"/>
                 </a:solidFill>
@@ -15743,236 +15441,60 @@
               </a:defRPr>
             </a:pPr>
             <a:r>
-              <a:t>Mie fresh direbus tepat 45 detik saat nota pesanan masuk dari kasir.</a:t>
-            </a:r>
-          </a:p>
-        </p:txBody>
-      </p:sp>
-      <p:sp>
-        <p:nvSpPr>
-          <p:cNvPr id="12" name="Rounded Rectangle 11"/>
+              <a:t>• A. Observasi lokasi Jl. Angsoka Hijau IV</a:t>
+            </a:r>
+          </a:p>
+          <a:p>
+            <a:pPr>
+              <a:defRPr sz="900">
+                <a:solidFill>
+                  <a:srgbClr val="0F172A"/>
+                </a:solidFill>
+                <a:latin typeface="Times New Roman"/>
+              </a:defRPr>
+            </a:pPr>
+            <a:r>
+              <a:t>• B. Negosiasi &amp; pelunasan sewa ruko Rp 20 Jt</a:t>
+            </a:r>
+          </a:p>
+          <a:p>
+            <a:pPr>
+              <a:defRPr sz="900">
+                <a:solidFill>
+                  <a:srgbClr val="0F172A"/>
+                </a:solidFill>
+                <a:latin typeface="Times New Roman"/>
+              </a:defRPr>
+            </a:pPr>
+            <a:r>
+              <a:t>• C. Izin lingkungan RT/RW &amp; retribusi</a:t>
+            </a:r>
+          </a:p>
+          <a:p>
+            <a:pPr>
+              <a:defRPr sz="900">
+                <a:solidFill>
+                  <a:srgbClr val="0F172A"/>
+                </a:solidFill>
+                <a:latin typeface="Times New Roman"/>
+              </a:defRPr>
+            </a:pPr>
+            <a:r>
+              <a:t>• D. Analisis potensi pasar murid Kalam Kudus</a:t>
+            </a:r>
+          </a:p>
+        </p:txBody>
+      </p:sp>
+      <p:sp>
+        <p:nvSpPr>
+          <p:cNvPr id="11" name="Rounded Rectangle 10"/>
           <p:cNvSpPr/>
           <p:nvPr/>
         </p:nvSpPr>
         <p:spPr>
           <a:xfrm>
-            <a:off x="9436608" y="1600200"/>
-            <a:ext cx="2011680" cy="2240280"/>
-          </a:xfrm>
-          <a:prstGeom prst="roundRect">
-            <a:avLst/>
-          </a:prstGeom>
-          <a:solidFill>
-            <a:srgbClr val="FFFFFF"/>
-          </a:solidFill>
-          <a:ln w="12700">
-            <a:solidFill>
-              <a:srgbClr val="CBD5E1"/>
-            </a:solidFill>
-          </a:ln>
-        </p:spPr>
-        <p:style>
-          <a:lnRef idx="1">
-            <a:schemeClr val="accent1"/>
-          </a:lnRef>
-          <a:fillRef idx="3">
-            <a:schemeClr val="accent1"/>
-          </a:fillRef>
-          <a:effectRef idx="2">
-            <a:schemeClr val="accent1"/>
-          </a:effectRef>
-          <a:fontRef idx="minor">
-            <a:schemeClr val="lt1"/>
-          </a:fontRef>
-        </p:style>
-        <p:txBody>
-          <a:bodyPr rtlCol="0" anchor="ctr" wrap="square" lIns="146304" rIns="146304" tIns="128016" bIns="128016"/>
-          <a:lstStyle/>
-          <a:p>
-            <a:pPr algn="ctr">
-              <a:defRPr sz="1100" b="1">
-                <a:solidFill>
-                  <a:srgbClr val="C27803"/>
-                </a:solidFill>
-                <a:latin typeface="Times New Roman"/>
-              </a:defRPr>
-            </a:pPr>
-            <a:r>
-              <a:t>LANGKAH 05</a:t>
-            </a:r>
-          </a:p>
-          <a:p>
-            <a:pPr>
-              <a:defRPr sz="1150" b="1">
-                <a:solidFill>
-                  <a:srgbClr val="0F294D"/>
-                </a:solidFill>
-                <a:latin typeface="Times New Roman"/>
-              </a:defRPr>
-            </a:pPr>
-            <a:r>
-              <a:t>Plating &amp; Penyajian</a:t>
-            </a:r>
-          </a:p>
-          <a:p>
-            <a:pPr>
-              <a:defRPr sz="1000" b="1">
-                <a:solidFill>
-                  <a:srgbClr val="1E3A8A"/>
-                </a:solidFill>
-                <a:latin typeface="Times New Roman"/>
-              </a:defRPr>
-            </a:pPr>
-            <a:r>
-              <a:t>Waktu: &lt; 5 Menit Total</a:t>
-            </a:r>
-          </a:p>
-          <a:p>
-            <a:br/>
-            <a:pPr>
-              <a:defRPr sz="950">
-                <a:solidFill>
-                  <a:srgbClr val="0F172A"/>
-                </a:solidFill>
-                <a:latin typeface="Times New Roman"/>
-              </a:defRPr>
-            </a:pPr>
-            <a:r>
-              <a:t>Pengadukan minyak pilihan, topping daging melimpah, daun bawang &amp; saus.</a:t>
-            </a:r>
-          </a:p>
-        </p:txBody>
-      </p:sp>
-      <p:sp>
-        <p:nvSpPr>
-          <p:cNvPr id="13" name="Rounded Rectangle 12"/>
-          <p:cNvSpPr/>
-          <p:nvPr/>
-        </p:nvSpPr>
-        <p:spPr>
-          <a:xfrm>
-            <a:off x="731520" y="3977639"/>
-            <a:ext cx="2542032" cy="2514600"/>
-          </a:xfrm>
-          <a:prstGeom prst="roundRect">
-            <a:avLst/>
-          </a:prstGeom>
-          <a:solidFill>
-            <a:srgbClr val="FFFFFF"/>
-          </a:solidFill>
-          <a:ln w="12700">
-            <a:solidFill>
-              <a:srgbClr val="C27803"/>
-            </a:solidFill>
-          </a:ln>
-        </p:spPr>
-        <p:style>
-          <a:lnRef idx="1">
-            <a:schemeClr val="accent1"/>
-          </a:lnRef>
-          <a:fillRef idx="3">
-            <a:schemeClr val="accent1"/>
-          </a:fillRef>
-          <a:effectRef idx="2">
-            <a:schemeClr val="accent1"/>
-          </a:effectRef>
-          <a:fontRef idx="minor">
-            <a:schemeClr val="lt1"/>
-          </a:fontRef>
-        </p:style>
-        <p:txBody>
-          <a:bodyPr rtlCol="0" anchor="ctr" wrap="square" lIns="146304" rIns="146304" tIns="128016" bIns="128016"/>
-          <a:lstStyle/>
-          <a:p>
-            <a:pPr algn="ctr">
-              <a:defRPr sz="1150" b="1">
-                <a:solidFill>
-                  <a:srgbClr val="C27803"/>
-                </a:solidFill>
-                <a:latin typeface="Times New Roman"/>
-              </a:defRPr>
-            </a:pPr>
-            <a:r>
-              <a:t>FASE 1: SURVEI &amp; SEWA</a:t>
-            </a:r>
-          </a:p>
-          <a:p>
-            <a:pPr>
-              <a:defRPr sz="1000" b="1">
-                <a:solidFill>
-                  <a:srgbClr val="475569"/>
-                </a:solidFill>
-                <a:latin typeface="Times New Roman"/>
-              </a:defRPr>
-            </a:pPr>
-            <a:r>
-              <a:t>Jadwal: Minggu 1 - 4</a:t>
-            </a:r>
-          </a:p>
-          <a:p>
-            <a:pPr>
-              <a:defRPr sz="950">
-                <a:solidFill>
-                  <a:srgbClr val="0F172A"/>
-                </a:solidFill>
-                <a:latin typeface="Times New Roman"/>
-              </a:defRPr>
-            </a:pPr>
-            <a:r>
-              <a:t>• A. Observasi lokasi Jl. Angsoka Hijau IV depan Kalam Kudus.</a:t>
-            </a:r>
-          </a:p>
-          <a:p>
-            <a:pPr>
-              <a:defRPr sz="950">
-                <a:solidFill>
-                  <a:srgbClr val="0F172A"/>
-                </a:solidFill>
-                <a:latin typeface="Times New Roman"/>
-              </a:defRPr>
-            </a:pPr>
-            <a:r>
-              <a:t>• B. Negosiasi dan pelunasan sewa ruko 1 lantai Rp 20 Juta.</a:t>
-            </a:r>
-          </a:p>
-          <a:p>
-            <a:pPr>
-              <a:defRPr sz="950">
-                <a:solidFill>
-                  <a:srgbClr val="0F172A"/>
-                </a:solidFill>
-                <a:latin typeface="Times New Roman"/>
-              </a:defRPr>
-            </a:pPr>
-            <a:r>
-              <a:t>• C. Izin lingkungan RT/RW dan retribusi kebersihan tertib.</a:t>
-            </a:r>
-          </a:p>
-          <a:p>
-            <a:pPr>
-              <a:defRPr sz="950">
-                <a:solidFill>
-                  <a:srgbClr val="0F172A"/>
-                </a:solidFill>
-                <a:latin typeface="Times New Roman"/>
-              </a:defRPr>
-            </a:pPr>
-            <a:r>
-              <a:t>• D. Analisis potensi pasar sarapan murid &amp; orang tua sekolah.</a:t>
-            </a:r>
-          </a:p>
-        </p:txBody>
-      </p:sp>
-      <p:sp>
-        <p:nvSpPr>
-          <p:cNvPr id="14" name="Rounded Rectangle 13"/>
-          <p:cNvSpPr/>
-          <p:nvPr/>
-        </p:nvSpPr>
-        <p:spPr>
-          <a:xfrm>
-            <a:off x="3456432" y="3977639"/>
-            <a:ext cx="2542032" cy="2514600"/>
+            <a:off x="3456432" y="4645152"/>
+            <a:ext cx="2542032" cy="1874519"/>
           </a:xfrm>
           <a:prstGeom prst="roundRect">
             <a:avLst/>
@@ -16005,7 +15527,7 @@
           <a:lstStyle/>
           <a:p>
             <a:pPr algn="ctr">
-              <a:defRPr sz="1150" b="1">
+              <a:defRPr sz="1050" b="1">
                 <a:solidFill>
                   <a:srgbClr val="1E3A8A"/>
                 </a:solidFill>
@@ -16018,7 +15540,7 @@
           </a:p>
           <a:p>
             <a:pPr>
-              <a:defRPr sz="1000" b="1">
+              <a:defRPr sz="950" b="1">
                 <a:solidFill>
                   <a:srgbClr val="475569"/>
                 </a:solidFill>
@@ -16031,7 +15553,7 @@
           </a:p>
           <a:p>
             <a:pPr>
-              <a:defRPr sz="950">
+              <a:defRPr sz="900">
                 <a:solidFill>
                   <a:srgbClr val="0F172A"/>
                 </a:solidFill>
@@ -16039,12 +15561,12 @@
               </a:defRPr>
             </a:pPr>
             <a:r>
-              <a:t>• E. Pengecatan ruko 1 lantai dan instalasi pipa saluran air.</a:t>
-            </a:r>
-          </a:p>
-          <a:p>
-            <a:pPr>
-              <a:defRPr sz="950">
+              <a:t>• E. Pengecatan ruko &amp; instalasi saluran air</a:t>
+            </a:r>
+          </a:p>
+          <a:p>
+            <a:pPr>
+              <a:defRPr sz="900">
                 <a:solidFill>
                   <a:srgbClr val="0F172A"/>
                 </a:solidFill>
@@ -16052,12 +15574,12 @@
               </a:defRPr>
             </a:pPr>
             <a:r>
-              <a:t>• F. Pemasangan 6 unit kipas angin dinding sejuk bebas pengap.</a:t>
-            </a:r>
-          </a:p>
-          <a:p>
-            <a:pPr>
-              <a:defRPr sz="950">
+              <a:t>• F. Pemasangan 6 unit kipas angin dinding</a:t>
+            </a:r>
+          </a:p>
+          <a:p>
+            <a:pPr>
+              <a:defRPr sz="900">
                 <a:solidFill>
                   <a:srgbClr val="0F172A"/>
                 </a:solidFill>
@@ -16065,12 +15587,12 @@
               </a:defRPr>
             </a:pPr>
             <a:r>
-              <a:t>• G. Penataan teras depan untuk stasiun open kitchen gerobak.</a:t>
-            </a:r>
-          </a:p>
-          <a:p>
-            <a:pPr>
-              <a:defRPr sz="950">
+              <a:t>• G. Pembuatan gerobak open kitchen teras</a:t>
+            </a:r>
+          </a:p>
+          <a:p>
+            <a:pPr>
+              <a:defRPr sz="900">
                 <a:solidFill>
                   <a:srgbClr val="0F172A"/>
                 </a:solidFill>
@@ -16078,21 +15600,21 @@
               </a:defRPr>
             </a:pPr>
             <a:r>
-              <a:t>• H. Pemasangan spanduk dan plang nama kedai Bakmi Mimu.</a:t>
-            </a:r>
-          </a:p>
-        </p:txBody>
-      </p:sp>
-      <p:sp>
-        <p:nvSpPr>
-          <p:cNvPr id="15" name="Rounded Rectangle 14"/>
+              <a:t>• H. Pemasangan spanduk &amp; plang nama kedai</a:t>
+            </a:r>
+          </a:p>
+        </p:txBody>
+      </p:sp>
+      <p:sp>
+        <p:nvSpPr>
+          <p:cNvPr id="12" name="Rounded Rectangle 11"/>
           <p:cNvSpPr/>
           <p:nvPr/>
         </p:nvSpPr>
         <p:spPr>
           <a:xfrm>
-            <a:off x="6181344" y="3977639"/>
-            <a:ext cx="2542032" cy="2514600"/>
+            <a:off x="6181344" y="4645152"/>
+            <a:ext cx="2542032" cy="1874519"/>
           </a:xfrm>
           <a:prstGeom prst="roundRect">
             <a:avLst/>
@@ -16125,7 +15647,7 @@
           <a:lstStyle/>
           <a:p>
             <a:pPr algn="ctr">
-              <a:defRPr sz="1150" b="1">
+              <a:defRPr sz="1050" b="1">
                 <a:solidFill>
                   <a:srgbClr val="059669"/>
                 </a:solidFill>
@@ -16133,12 +15655,12 @@
               </a:defRPr>
             </a:pPr>
             <a:r>
-              <a:t>FASE 3: PENGADAAN &amp; SETTING</a:t>
-            </a:r>
-          </a:p>
-          <a:p>
-            <a:pPr>
-              <a:defRPr sz="1000" b="1">
+              <a:t>FASE 3: PENGADAAN ALAT</a:t>
+            </a:r>
+          </a:p>
+          <a:p>
+            <a:pPr>
+              <a:defRPr sz="950" b="1">
                 <a:solidFill>
                   <a:srgbClr val="475569"/>
                 </a:solidFill>
@@ -16151,7 +15673,7 @@
           </a:p>
           <a:p>
             <a:pPr>
-              <a:defRPr sz="950">
+              <a:defRPr sz="900">
                 <a:solidFill>
                   <a:srgbClr val="0F172A"/>
                 </a:solidFill>
@@ -16159,12 +15681,12 @@
               </a:defRPr>
             </a:pPr>
             <a:r>
-              <a:t>• I. Pembuatan gerobak etalase kaca stasiun masak (Rp 8 Jt).</a:t>
-            </a:r>
-          </a:p>
-          <a:p>
-            <a:pPr>
-              <a:defRPr sz="950">
+              <a:t>• I. Pengadaan 4 meja &amp; kursi santap 37 pcs</a:t>
+            </a:r>
+          </a:p>
+          <a:p>
+            <a:pPr>
+              <a:defRPr sz="900">
                 <a:solidFill>
                   <a:srgbClr val="0F172A"/>
                 </a:solidFill>
@@ -16172,12 +15694,12 @@
               </a:defRPr>
             </a:pPr>
             <a:r>
-              <a:t>• J. Pengadaan 4 meja pendek, meja dinding, dan kursi 37 pcs.</a:t>
-            </a:r>
-          </a:p>
-          <a:p>
-            <a:pPr>
-              <a:defRPr sz="950">
+              <a:t>• J. Pembelian kulkas sayur, freezer &amp; panci</a:t>
+            </a:r>
+          </a:p>
+          <a:p>
+            <a:pPr>
+              <a:defRPr sz="900">
                 <a:solidFill>
                   <a:srgbClr val="0F172A"/>
                 </a:solidFill>
@@ -16185,12 +15707,12 @@
               </a:defRPr>
             </a:pPr>
             <a:r>
-              <a:t>• K. Pembelian kulkas sayur, freezer daging, panci &amp; mangkok.</a:t>
-            </a:r>
-          </a:p>
-          <a:p>
-            <a:pPr>
-              <a:defRPr sz="950">
+              <a:t>• K. Setting tata letak ruko 23 kursi aktif</a:t>
+            </a:r>
+          </a:p>
+          <a:p>
+            <a:pPr>
+              <a:defRPr sz="900">
                 <a:solidFill>
                   <a:srgbClr val="0F172A"/>
                 </a:solidFill>
@@ -16198,21 +15720,21 @@
               </a:defRPr>
             </a:pPr>
             <a:r>
-              <a:t>• L. Pengadaan saus standar resmi (Belibis &amp; Mangga Besar).</a:t>
-            </a:r>
-          </a:p>
-        </p:txBody>
-      </p:sp>
-      <p:sp>
-        <p:nvSpPr>
-          <p:cNvPr id="16" name="Rounded Rectangle 15"/>
+              <a:t>• L. Stok saus resmi Belibis &amp; Mangga Besar</a:t>
+            </a:r>
+          </a:p>
+        </p:txBody>
+      </p:sp>
+      <p:sp>
+        <p:nvSpPr>
+          <p:cNvPr id="13" name="Rounded Rectangle 12"/>
           <p:cNvSpPr/>
           <p:nvPr/>
         </p:nvSpPr>
         <p:spPr>
           <a:xfrm>
-            <a:off x="8906256" y="3977639"/>
-            <a:ext cx="2542032" cy="2514600"/>
+            <a:off x="8906256" y="4645152"/>
+            <a:ext cx="2542032" cy="1874519"/>
           </a:xfrm>
           <a:prstGeom prst="roundRect">
             <a:avLst/>
@@ -16245,7 +15767,7 @@
           <a:lstStyle/>
           <a:p>
             <a:pPr algn="ctr">
-              <a:defRPr sz="1150" b="1">
+              <a:defRPr sz="1050" b="1">
                 <a:solidFill>
                   <a:srgbClr val="0F294D"/>
                 </a:solidFill>
@@ -16258,7 +15780,7 @@
           </a:p>
           <a:p>
             <a:pPr>
-              <a:defRPr sz="1000" b="1">
+              <a:defRPr sz="950" b="1">
                 <a:solidFill>
                   <a:srgbClr val="475569"/>
                 </a:solidFill>
@@ -16271,7 +15793,7 @@
           </a:p>
           <a:p>
             <a:pPr>
-              <a:defRPr sz="950">
+              <a:defRPr sz="900">
                 <a:solidFill>
                   <a:srgbClr val="0F172A"/>
                 </a:solidFill>
@@ -16279,12 +15801,12 @@
               </a:defRPr>
             </a:pPr>
             <a:r>
-              <a:t>• M. Rekrutmen 3 karyawan tetap (Koki, Asisten, Kasir-Pramusaji).</a:t>
-            </a:r>
-          </a:p>
-          <a:p>
-            <a:pPr>
-              <a:defRPr sz="950">
+              <a:t>• M. Rekrutmen 3 karyawan tetap (Koki-Kasir)</a:t>
+            </a:r>
+          </a:p>
+          <a:p>
+            <a:pPr>
+              <a:defRPr sz="900">
                 <a:solidFill>
                   <a:srgbClr val="0F172A"/>
                 </a:solidFill>
@@ -16292,12 +15814,12 @@
               </a:defRPr>
             </a:pPr>
             <a:r>
-              <a:t>• N. Uji coba pembuatan adonan mie mingguan &amp; kaldu resep 1999.</a:t>
-            </a:r>
-          </a:p>
-          <a:p>
-            <a:pPr>
-              <a:defRPr sz="950">
+              <a:t>• N. Pelatihan adonan mingguan &amp; kaldu 1999</a:t>
+            </a:r>
+          </a:p>
+          <a:p>
+            <a:pPr>
+              <a:defRPr sz="900">
                 <a:solidFill>
                   <a:srgbClr val="0F172A"/>
                 </a:solidFill>
@@ -16305,12 +15827,12 @@
               </a:defRPr>
             </a:pPr>
             <a:r>
-              <a:t>• O. Simulasi alur pelayanan dine-in 23 kursi dan nota manual.</a:t>
-            </a:r>
-          </a:p>
-          <a:p>
-            <a:pPr>
-              <a:defRPr sz="950">
+              <a:t>• O. Simulasi alur santap dine-in &amp; nota manual</a:t>
+            </a:r>
+          </a:p>
+          <a:p>
+            <a:pPr>
+              <a:defRPr sz="900">
                 <a:solidFill>
                   <a:srgbClr val="0F172A"/>
                 </a:solidFill>
@@ -16318,7 +15840,7 @@
               </a:defRPr>
             </a:pPr>
             <a:r>
-              <a:t>• P. Pembukaan resmi melayani warga perumahan Kosambi.</a:t>
+              <a:t>• P. Grand Opening resmi melayani warga Kosambi</a:t>
             </a:r>
           </a:p>
         </p:txBody>

</xml_diff>

<commit_message>
feat(assets): integrate authentic field photography into visual assets and optimize presentation layout proportions
</commit_message>
<xml_diff>
--- a/01_TUGAS_FINAL_BAKMI_MIMU/Presentasi_SKB_Bakmi_Mimu_Carina_Sayang.pptx
+++ b/01_TUGAS_FINAL_BAKMI_MIMU/Presentasi_SKB_Bakmi_Mimu_Carina_Sayang.pptx
@@ -13844,7 +13844,7 @@
         <p:spPr>
           <a:xfrm>
             <a:off x="731520" y="1600200"/>
-            <a:ext cx="10728655" cy="2907792"/>
+            <a:ext cx="10728655" cy="4160520"/>
           </a:xfrm>
           <a:prstGeom prst="roundRect">
             <a:avLst/>
@@ -13885,7 +13885,7 @@
               </a:defRPr>
             </a:pPr>
             <a:r>
-              <a:t>BAGAN STRUKTUR ORGANISASI KEDAI (GAMBAR 3.1 ACUAN RESMI)</a:t>
+              <a:t>BAGAN STRUKTUR ORGANISASI FUNGSIONAL KEDAI (GAMBAR 3.1 ACUAN RESMI)</a:t>
             </a:r>
           </a:p>
           <a:p>
@@ -13898,7 +13898,7 @@
               </a:defRPr>
             </a:pPr>
             <a:r>
-              <a:t>Hierarki Organisasi: Owner / Pengelola Utama ➔ 3 Staf Karyawan Tetap (Koki Utama, Asisten Koki, Kasir &amp; Pramusaji)</a:t>
+              <a:t>Garis Komando: Owner / Pengelola Utama ➔ 3 Staf Fungsional Inti (Koki Utama, Asisten Koki, Kasir &amp; Pramusaji)</a:t>
             </a:r>
           </a:p>
         </p:txBody>
@@ -13919,8 +13919,8 @@
         </p:blipFill>
         <p:spPr>
           <a:xfrm>
-            <a:off x="1889607" y="2240280"/>
-            <a:ext cx="8412480" cy="2148840"/>
+            <a:off x="2851333" y="2121408"/>
+            <a:ext cx="6489027" cy="3520440"/>
           </a:xfrm>
           <a:prstGeom prst="rect">
             <a:avLst/>
@@ -13935,228 +13935,14 @@
         </p:nvSpPr>
         <p:spPr>
           <a:xfrm>
-            <a:off x="731520" y="4645152"/>
-            <a:ext cx="3429000" cy="1874519"/>
+            <a:off x="731520" y="5833872"/>
+            <a:ext cx="10728655" cy="658368"/>
           </a:xfrm>
           <a:prstGeom prst="roundRect">
             <a:avLst/>
           </a:prstGeom>
           <a:solidFill>
-            <a:srgbClr val="FFFFFF"/>
-          </a:solidFill>
-          <a:ln w="12700">
-            <a:solidFill>
-              <a:srgbClr val="1E3A8A"/>
-            </a:solidFill>
-          </a:ln>
-        </p:spPr>
-        <p:style>
-          <a:lnRef idx="1">
-            <a:schemeClr val="accent1"/>
-          </a:lnRef>
-          <a:fillRef idx="3">
-            <a:schemeClr val="accent1"/>
-          </a:fillRef>
-          <a:effectRef idx="2">
-            <a:schemeClr val="accent1"/>
-          </a:effectRef>
-          <a:fontRef idx="minor">
-            <a:schemeClr val="lt1"/>
-          </a:fontRef>
-        </p:style>
-        <p:txBody>
-          <a:bodyPr rtlCol="0" anchor="ctr" wrap="square" lIns="146304" rIns="146304" tIns="128016" bIns="128016"/>
-          <a:lstStyle/>
-          <a:p>
-            <a:pPr algn="ctr">
-              <a:defRPr sz="1100" b="1">
-                <a:solidFill>
-                  <a:srgbClr val="1E3A8A"/>
-                </a:solidFill>
-                <a:latin typeface="Times New Roman"/>
-              </a:defRPr>
-            </a:pPr>
-            <a:r>
-              <a:t>KOKI UTAMA (RP 3.800.000 / BLN)</a:t>
-            </a:r>
-          </a:p>
-          <a:p>
-            <a:pPr>
-              <a:defRPr sz="950">
-                <a:solidFill>
-                  <a:srgbClr val="0F172A"/>
-                </a:solidFill>
-                <a:latin typeface="Times New Roman"/>
-              </a:defRPr>
-            </a:pPr>
-            <a:r>
-              <a:t>• Membuat adonan mie fresh setiap minggu tanpa formalin</a:t>
-            </a:r>
-          </a:p>
-          <a:p>
-            <a:pPr>
-              <a:defRPr sz="950">
-                <a:solidFill>
-                  <a:srgbClr val="0F172A"/>
-                </a:solidFill>
-                <a:latin typeface="Times New Roman"/>
-              </a:defRPr>
-            </a:pPr>
-            <a:r>
-              <a:t>• Memasak 3 topping: ayam putih, babi kecap, casiu madu</a:t>
-            </a:r>
-          </a:p>
-          <a:p>
-            <a:pPr>
-              <a:defRPr sz="950">
-                <a:solidFill>
-                  <a:srgbClr val="0F172A"/>
-                </a:solidFill>
-                <a:latin typeface="Times New Roman"/>
-              </a:defRPr>
-            </a:pPr>
-            <a:r>
-              <a:t>• Menyiapkan 3 racikan minyak khas &amp; kaldu rebusan</a:t>
-            </a:r>
-          </a:p>
-          <a:p>
-            <a:pPr>
-              <a:defRPr sz="950">
-                <a:solidFill>
-                  <a:srgbClr val="0F172A"/>
-                </a:solidFill>
-                <a:latin typeface="Times New Roman"/>
-              </a:defRPr>
-            </a:pPr>
-            <a:r>
-              <a:t>• Memimpin perebusan mie kilat 45 detik di open kitchen</a:t>
-            </a:r>
-          </a:p>
-        </p:txBody>
-      </p:sp>
-      <p:sp>
-        <p:nvSpPr>
-          <p:cNvPr id="11" name="Rounded Rectangle 10"/>
-          <p:cNvSpPr/>
-          <p:nvPr/>
-        </p:nvSpPr>
-        <p:spPr>
-          <a:xfrm>
-            <a:off x="4379976" y="4645152"/>
-            <a:ext cx="3429000" cy="1874519"/>
-          </a:xfrm>
-          <a:prstGeom prst="roundRect">
-            <a:avLst/>
-          </a:prstGeom>
-          <a:solidFill>
-            <a:srgbClr val="FFFFFF"/>
-          </a:solidFill>
-          <a:ln w="12700">
-            <a:solidFill>
-              <a:srgbClr val="059669"/>
-            </a:solidFill>
-          </a:ln>
-        </p:spPr>
-        <p:style>
-          <a:lnRef idx="1">
-            <a:schemeClr val="accent1"/>
-          </a:lnRef>
-          <a:fillRef idx="3">
-            <a:schemeClr val="accent1"/>
-          </a:fillRef>
-          <a:effectRef idx="2">
-            <a:schemeClr val="accent1"/>
-          </a:effectRef>
-          <a:fontRef idx="minor">
-            <a:schemeClr val="lt1"/>
-          </a:fontRef>
-        </p:style>
-        <p:txBody>
-          <a:bodyPr rtlCol="0" anchor="ctr" wrap="square" lIns="146304" rIns="146304" tIns="128016" bIns="128016"/>
-          <a:lstStyle/>
-          <a:p>
-            <a:pPr algn="ctr">
-              <a:defRPr sz="1100" b="1">
-                <a:solidFill>
-                  <a:srgbClr val="059669"/>
-                </a:solidFill>
-                <a:latin typeface="Times New Roman"/>
-              </a:defRPr>
-            </a:pPr>
-            <a:r>
-              <a:t>ASISTEN KOKI (RP 3.200.000 / BLN)</a:t>
-            </a:r>
-          </a:p>
-          <a:p>
-            <a:pPr>
-              <a:defRPr sz="950">
-                <a:solidFill>
-                  <a:srgbClr val="0F172A"/>
-                </a:solidFill>
-                <a:latin typeface="Times New Roman"/>
-              </a:defRPr>
-            </a:pPr>
-            <a:r>
-              <a:t>• Menyiapkan bahan mentah &amp; bumbu rempah dapur</a:t>
-            </a:r>
-          </a:p>
-          <a:p>
-            <a:pPr>
-              <a:defRPr sz="950">
-                <a:solidFill>
-                  <a:srgbClr val="0F172A"/>
-                </a:solidFill>
-                <a:latin typeface="Times New Roman"/>
-              </a:defRPr>
-            </a:pPr>
-            <a:r>
-              <a:t>• Melipat kulit pangsit &amp; swikiaw isian babi-udang</a:t>
-            </a:r>
-          </a:p>
-          <a:p>
-            <a:pPr>
-              <a:defRPr sz="950">
-                <a:solidFill>
-                  <a:srgbClr val="0F172A"/>
-                </a:solidFill>
-                <a:latin typeface="Times New Roman"/>
-              </a:defRPr>
-            </a:pPr>
-            <a:r>
-              <a:t>• Mencuci mangkok keramik, piring, sumpit &amp; panci masak</a:t>
-            </a:r>
-          </a:p>
-          <a:p>
-            <a:pPr>
-              <a:defRPr sz="950">
-                <a:solidFill>
-                  <a:srgbClr val="0F172A"/>
-                </a:solidFill>
-                <a:latin typeface="Times New Roman"/>
-              </a:defRPr>
-            </a:pPr>
-            <a:r>
-              <a:t>• Menjaga sanitasi higienis stasiun gerobak teras kedai</a:t>
-            </a:r>
-          </a:p>
-        </p:txBody>
-      </p:sp>
-      <p:sp>
-        <p:nvSpPr>
-          <p:cNvPr id="12" name="Rounded Rectangle 11"/>
-          <p:cNvSpPr/>
-          <p:nvPr/>
-        </p:nvSpPr>
-        <p:spPr>
-          <a:xfrm>
-            <a:off x="8028431" y="4645152"/>
-            <a:ext cx="3429000" cy="1874519"/>
-          </a:xfrm>
-          <a:prstGeom prst="roundRect">
-            <a:avLst/>
-          </a:prstGeom>
-          <a:solidFill>
-            <a:srgbClr val="FFFFFF"/>
+            <a:srgbClr val="F1F5F9"/>
           </a:solidFill>
           <a:ln w="12700">
             <a:solidFill>
@@ -14183,67 +13969,28 @@
           <a:lstStyle/>
           <a:p>
             <a:pPr algn="ctr">
-              <a:defRPr sz="1100" b="1">
-                <a:solidFill>
-                  <a:srgbClr val="C27803"/>
-                </a:solidFill>
-                <a:latin typeface="Times New Roman"/>
-              </a:defRPr>
-            </a:pPr>
-            <a:r>
-              <a:t>KASIR &amp; PRAMUSAJI (RP 3.000.000 / BLN)</a:t>
+              <a:defRPr sz="1050" b="1">
+                <a:solidFill>
+                  <a:srgbClr val="0F294D"/>
+                </a:solidFill>
+                <a:latin typeface="Times New Roman"/>
+              </a:defRPr>
+            </a:pPr>
+            <a:r>
+              <a:t>TOTAL FORMASI SDM: 1 OWNER (PENGELOLA) + 3 KARYAWAN TETAP  |  TOTAL ALOKASI UPAH: RP 10.000.000 / BULAN (RP 120.000.000 / TAHUN)</a:t>
             </a:r>
           </a:p>
           <a:p>
             <a:pPr>
               <a:defRPr sz="950">
                 <a:solidFill>
-                  <a:srgbClr val="0F172A"/>
-                </a:solidFill>
-                <a:latin typeface="Times New Roman"/>
-              </a:defRPr>
-            </a:pPr>
-            <a:r>
-              <a:t>• Mencatat pesanan pelanggan dengan nota manual tertib</a:t>
-            </a:r>
-          </a:p>
-          <a:p>
-            <a:pPr>
-              <a:defRPr sz="950">
-                <a:solidFill>
-                  <a:srgbClr val="0F172A"/>
-                </a:solidFill>
-                <a:latin typeface="Times New Roman"/>
-              </a:defRPr>
-            </a:pPr>
-            <a:r>
-              <a:t>• Melayani pembayaran tunai &amp; transaksi QRIS</a:t>
-            </a:r>
-          </a:p>
-          <a:p>
-            <a:pPr>
-              <a:defRPr sz="950">
-                <a:solidFill>
-                  <a:srgbClr val="0F172A"/>
-                </a:solidFill>
-                <a:latin typeface="Times New Roman"/>
-              </a:defRPr>
-            </a:pPr>
-            <a:r>
-              <a:t>• Menyajikan mangkok mie &amp; minuman ke 23 kursi tamu</a:t>
-            </a:r>
-          </a:p>
-          <a:p>
-            <a:pPr>
-              <a:defRPr sz="950">
-                <a:solidFill>
-                  <a:srgbClr val="0F172A"/>
-                </a:solidFill>
-                <a:latin typeface="Times New Roman"/>
-              </a:defRPr>
-            </a:pPr>
-            <a:r>
-              <a:t>• Membersihkan meja makan &amp; melayani pesanan take-away</a:t>
+                  <a:srgbClr val="475569"/>
+                </a:solidFill>
+                <a:latin typeface="Times New Roman"/>
+              </a:defRPr>
+            </a:pPr>
+            <a:r>
+              <a:t>Rincian Gaji: Koki Utama Rp 3,8 Jt, Asisten Koki Rp 3,2 Jt, Kasir-Pramusaji Rp 3,0 Jt  |  Fasilitas: Gaji Tetap, Makan Harian Kedai, &amp; THR Tahunan</a:t>
             </a:r>
           </a:p>
         </p:txBody>
@@ -14638,8 +14385,8 @@
         </p:blipFill>
         <p:spPr>
           <a:xfrm>
-            <a:off x="1889607" y="2240280"/>
-            <a:ext cx="8412480" cy="2148840"/>
+            <a:off x="1573723" y="2121408"/>
+            <a:ext cx="9044247" cy="2331720"/>
           </a:xfrm>
           <a:prstGeom prst="rect">
             <a:avLst/>
@@ -15282,7 +15029,7 @@
         <p:spPr>
           <a:xfrm>
             <a:off x="731520" y="1600200"/>
-            <a:ext cx="10728655" cy="2907792"/>
+            <a:ext cx="10728655" cy="4160520"/>
           </a:xfrm>
           <a:prstGeom prst="roundRect">
             <a:avLst/>
@@ -15336,7 +15083,7 @@
               </a:defRPr>
             </a:pPr>
             <a:r>
-              <a:t>Jalur Kritis 12 Minggu: A (Survei 2 mg) ➔ B (Sewa 2 mg) ➔ E (Renovasi 1 mg) ➔ G (Gerobak 2 mg) ➔ I (Meja/Kursi 2 mg) ➔ K (Setting 1 mg) ➔ M-P (Buka 2 mg)</a:t>
+              <a:t>Alur Kritis 12 Minggu: A (Survei 2 mg) ➔ B (Sewa 2 mg) ➔ E (Renovasi 1 mg) ➔ G (Gerobak 2 mg) ➔ I (Meja/Kursi 2 mg) ➔ K (Setting 1 mg) ➔ M-P (Buka 2 mg)</a:t>
             </a:r>
           </a:p>
         </p:txBody>
@@ -15357,8 +15104,8 @@
         </p:blipFill>
         <p:spPr>
           <a:xfrm>
-            <a:off x="1889607" y="2240280"/>
-            <a:ext cx="8412480" cy="2148840"/>
+            <a:off x="2851333" y="2121408"/>
+            <a:ext cx="6489027" cy="3520440"/>
           </a:xfrm>
           <a:prstGeom prst="rect">
             <a:avLst/>
@@ -15373,14 +15120,14 @@
         </p:nvSpPr>
         <p:spPr>
           <a:xfrm>
-            <a:off x="731520" y="4645152"/>
-            <a:ext cx="2542032" cy="1874519"/>
+            <a:off x="731520" y="5833872"/>
+            <a:ext cx="10728655" cy="658368"/>
           </a:xfrm>
           <a:prstGeom prst="roundRect">
             <a:avLst/>
           </a:prstGeom>
           <a:solidFill>
-            <a:srgbClr val="FFFFFF"/>
+            <a:srgbClr val="F1F5F9"/>
           </a:solidFill>
           <a:ln w="12700">
             <a:solidFill>
@@ -15415,12 +15162,12 @@
               </a:defRPr>
             </a:pPr>
             <a:r>
-              <a:t>FASE 1: SURVEI &amp; SEWA</a:t>
+              <a:t>JALUR KRITIS (CRITICAL PATH METHOD): 1 ➔ 2 ➔ 3 ➔ 5 ➔ 6 ➔ 8 ➔ 10 ➔ 11  |  TOTAL DURASI RELOKASI: 12 MINGGU</a:t>
             </a:r>
           </a:p>
           <a:p>
             <a:pPr>
-              <a:defRPr sz="950" b="1">
+              <a:defRPr sz="950">
                 <a:solidFill>
                   <a:srgbClr val="475569"/>
                 </a:solidFill>
@@ -15428,419 +15175,7 @@
               </a:defRPr>
             </a:pPr>
             <a:r>
-              <a:t>Jadwal: Minggu 1 - 4</a:t>
-            </a:r>
-          </a:p>
-          <a:p>
-            <a:pPr>
-              <a:defRPr sz="900">
-                <a:solidFill>
-                  <a:srgbClr val="0F172A"/>
-                </a:solidFill>
-                <a:latin typeface="Times New Roman"/>
-              </a:defRPr>
-            </a:pPr>
-            <a:r>
-              <a:t>• A. Observasi lokasi Jl. Angsoka Hijau IV</a:t>
-            </a:r>
-          </a:p>
-          <a:p>
-            <a:pPr>
-              <a:defRPr sz="900">
-                <a:solidFill>
-                  <a:srgbClr val="0F172A"/>
-                </a:solidFill>
-                <a:latin typeface="Times New Roman"/>
-              </a:defRPr>
-            </a:pPr>
-            <a:r>
-              <a:t>• B. Negosiasi &amp; pelunasan sewa ruko Rp 20 Jt</a:t>
-            </a:r>
-          </a:p>
-          <a:p>
-            <a:pPr>
-              <a:defRPr sz="900">
-                <a:solidFill>
-                  <a:srgbClr val="0F172A"/>
-                </a:solidFill>
-                <a:latin typeface="Times New Roman"/>
-              </a:defRPr>
-            </a:pPr>
-            <a:r>
-              <a:t>• C. Izin lingkungan RT/RW &amp; retribusi</a:t>
-            </a:r>
-          </a:p>
-          <a:p>
-            <a:pPr>
-              <a:defRPr sz="900">
-                <a:solidFill>
-                  <a:srgbClr val="0F172A"/>
-                </a:solidFill>
-                <a:latin typeface="Times New Roman"/>
-              </a:defRPr>
-            </a:pPr>
-            <a:r>
-              <a:t>• D. Analisis potensi pasar murid Kalam Kudus</a:t>
-            </a:r>
-          </a:p>
-        </p:txBody>
-      </p:sp>
-      <p:sp>
-        <p:nvSpPr>
-          <p:cNvPr id="11" name="Rounded Rectangle 10"/>
-          <p:cNvSpPr/>
-          <p:nvPr/>
-        </p:nvSpPr>
-        <p:spPr>
-          <a:xfrm>
-            <a:off x="3456432" y="4645152"/>
-            <a:ext cx="2542032" cy="1874519"/>
-          </a:xfrm>
-          <a:prstGeom prst="roundRect">
-            <a:avLst/>
-          </a:prstGeom>
-          <a:solidFill>
-            <a:srgbClr val="FFFFFF"/>
-          </a:solidFill>
-          <a:ln w="12700">
-            <a:solidFill>
-              <a:srgbClr val="1E3A8A"/>
-            </a:solidFill>
-          </a:ln>
-        </p:spPr>
-        <p:style>
-          <a:lnRef idx="1">
-            <a:schemeClr val="accent1"/>
-          </a:lnRef>
-          <a:fillRef idx="3">
-            <a:schemeClr val="accent1"/>
-          </a:fillRef>
-          <a:effectRef idx="2">
-            <a:schemeClr val="accent1"/>
-          </a:effectRef>
-          <a:fontRef idx="minor">
-            <a:schemeClr val="lt1"/>
-          </a:fontRef>
-        </p:style>
-        <p:txBody>
-          <a:bodyPr rtlCol="0" anchor="ctr" wrap="square" lIns="146304" rIns="146304" tIns="128016" bIns="128016"/>
-          <a:lstStyle/>
-          <a:p>
-            <a:pPr algn="ctr">
-              <a:defRPr sz="1050" b="1">
-                <a:solidFill>
-                  <a:srgbClr val="1E3A8A"/>
-                </a:solidFill>
-                <a:latin typeface="Times New Roman"/>
-              </a:defRPr>
-            </a:pPr>
-            <a:r>
-              <a:t>FASE 2: RENOVASI &amp; FIT-OUT</a:t>
-            </a:r>
-          </a:p>
-          <a:p>
-            <a:pPr>
-              <a:defRPr sz="950" b="1">
-                <a:solidFill>
-                  <a:srgbClr val="475569"/>
-                </a:solidFill>
-                <a:latin typeface="Times New Roman"/>
-              </a:defRPr>
-            </a:pPr>
-            <a:r>
-              <a:t>Jadwal: Minggu 5 - 8</a:t>
-            </a:r>
-          </a:p>
-          <a:p>
-            <a:pPr>
-              <a:defRPr sz="900">
-                <a:solidFill>
-                  <a:srgbClr val="0F172A"/>
-                </a:solidFill>
-                <a:latin typeface="Times New Roman"/>
-              </a:defRPr>
-            </a:pPr>
-            <a:r>
-              <a:t>• E. Pengecatan ruko &amp; instalasi saluran air</a:t>
-            </a:r>
-          </a:p>
-          <a:p>
-            <a:pPr>
-              <a:defRPr sz="900">
-                <a:solidFill>
-                  <a:srgbClr val="0F172A"/>
-                </a:solidFill>
-                <a:latin typeface="Times New Roman"/>
-              </a:defRPr>
-            </a:pPr>
-            <a:r>
-              <a:t>• F. Pemasangan 6 unit kipas angin dinding</a:t>
-            </a:r>
-          </a:p>
-          <a:p>
-            <a:pPr>
-              <a:defRPr sz="900">
-                <a:solidFill>
-                  <a:srgbClr val="0F172A"/>
-                </a:solidFill>
-                <a:latin typeface="Times New Roman"/>
-              </a:defRPr>
-            </a:pPr>
-            <a:r>
-              <a:t>• G. Pembuatan gerobak open kitchen teras</a:t>
-            </a:r>
-          </a:p>
-          <a:p>
-            <a:pPr>
-              <a:defRPr sz="900">
-                <a:solidFill>
-                  <a:srgbClr val="0F172A"/>
-                </a:solidFill>
-                <a:latin typeface="Times New Roman"/>
-              </a:defRPr>
-            </a:pPr>
-            <a:r>
-              <a:t>• H. Pemasangan spanduk &amp; plang nama kedai</a:t>
-            </a:r>
-          </a:p>
-        </p:txBody>
-      </p:sp>
-      <p:sp>
-        <p:nvSpPr>
-          <p:cNvPr id="12" name="Rounded Rectangle 11"/>
-          <p:cNvSpPr/>
-          <p:nvPr/>
-        </p:nvSpPr>
-        <p:spPr>
-          <a:xfrm>
-            <a:off x="6181344" y="4645152"/>
-            <a:ext cx="2542032" cy="1874519"/>
-          </a:xfrm>
-          <a:prstGeom prst="roundRect">
-            <a:avLst/>
-          </a:prstGeom>
-          <a:solidFill>
-            <a:srgbClr val="FFFFFF"/>
-          </a:solidFill>
-          <a:ln w="12700">
-            <a:solidFill>
-              <a:srgbClr val="059669"/>
-            </a:solidFill>
-          </a:ln>
-        </p:spPr>
-        <p:style>
-          <a:lnRef idx="1">
-            <a:schemeClr val="accent1"/>
-          </a:lnRef>
-          <a:fillRef idx="3">
-            <a:schemeClr val="accent1"/>
-          </a:fillRef>
-          <a:effectRef idx="2">
-            <a:schemeClr val="accent1"/>
-          </a:effectRef>
-          <a:fontRef idx="minor">
-            <a:schemeClr val="lt1"/>
-          </a:fontRef>
-        </p:style>
-        <p:txBody>
-          <a:bodyPr rtlCol="0" anchor="ctr" wrap="square" lIns="146304" rIns="146304" tIns="128016" bIns="128016"/>
-          <a:lstStyle/>
-          <a:p>
-            <a:pPr algn="ctr">
-              <a:defRPr sz="1050" b="1">
-                <a:solidFill>
-                  <a:srgbClr val="059669"/>
-                </a:solidFill>
-                <a:latin typeface="Times New Roman"/>
-              </a:defRPr>
-            </a:pPr>
-            <a:r>
-              <a:t>FASE 3: PENGADAAN ALAT</a:t>
-            </a:r>
-          </a:p>
-          <a:p>
-            <a:pPr>
-              <a:defRPr sz="950" b="1">
-                <a:solidFill>
-                  <a:srgbClr val="475569"/>
-                </a:solidFill>
-                <a:latin typeface="Times New Roman"/>
-              </a:defRPr>
-            </a:pPr>
-            <a:r>
-              <a:t>Jadwal: Minggu 9 - 10</a:t>
-            </a:r>
-          </a:p>
-          <a:p>
-            <a:pPr>
-              <a:defRPr sz="900">
-                <a:solidFill>
-                  <a:srgbClr val="0F172A"/>
-                </a:solidFill>
-                <a:latin typeface="Times New Roman"/>
-              </a:defRPr>
-            </a:pPr>
-            <a:r>
-              <a:t>• I. Pengadaan 4 meja &amp; kursi santap 37 pcs</a:t>
-            </a:r>
-          </a:p>
-          <a:p>
-            <a:pPr>
-              <a:defRPr sz="900">
-                <a:solidFill>
-                  <a:srgbClr val="0F172A"/>
-                </a:solidFill>
-                <a:latin typeface="Times New Roman"/>
-              </a:defRPr>
-            </a:pPr>
-            <a:r>
-              <a:t>• J. Pembelian kulkas sayur, freezer &amp; panci</a:t>
-            </a:r>
-          </a:p>
-          <a:p>
-            <a:pPr>
-              <a:defRPr sz="900">
-                <a:solidFill>
-                  <a:srgbClr val="0F172A"/>
-                </a:solidFill>
-                <a:latin typeface="Times New Roman"/>
-              </a:defRPr>
-            </a:pPr>
-            <a:r>
-              <a:t>• K. Setting tata letak ruko 23 kursi aktif</a:t>
-            </a:r>
-          </a:p>
-          <a:p>
-            <a:pPr>
-              <a:defRPr sz="900">
-                <a:solidFill>
-                  <a:srgbClr val="0F172A"/>
-                </a:solidFill>
-                <a:latin typeface="Times New Roman"/>
-              </a:defRPr>
-            </a:pPr>
-            <a:r>
-              <a:t>• L. Stok saus resmi Belibis &amp; Mangga Besar</a:t>
-            </a:r>
-          </a:p>
-        </p:txBody>
-      </p:sp>
-      <p:sp>
-        <p:nvSpPr>
-          <p:cNvPr id="13" name="Rounded Rectangle 12"/>
-          <p:cNvSpPr/>
-          <p:nvPr/>
-        </p:nvSpPr>
-        <p:spPr>
-          <a:xfrm>
-            <a:off x="8906256" y="4645152"/>
-            <a:ext cx="2542032" cy="1874519"/>
-          </a:xfrm>
-          <a:prstGeom prst="roundRect">
-            <a:avLst/>
-          </a:prstGeom>
-          <a:solidFill>
-            <a:srgbClr val="FFFFFF"/>
-          </a:solidFill>
-          <a:ln w="12700">
-            <a:solidFill>
-              <a:srgbClr val="0F294D"/>
-            </a:solidFill>
-          </a:ln>
-        </p:spPr>
-        <p:style>
-          <a:lnRef idx="1">
-            <a:schemeClr val="accent1"/>
-          </a:lnRef>
-          <a:fillRef idx="3">
-            <a:schemeClr val="accent1"/>
-          </a:fillRef>
-          <a:effectRef idx="2">
-            <a:schemeClr val="accent1"/>
-          </a:effectRef>
-          <a:fontRef idx="minor">
-            <a:schemeClr val="lt1"/>
-          </a:fontRef>
-        </p:style>
-        <p:txBody>
-          <a:bodyPr rtlCol="0" anchor="ctr" wrap="square" lIns="146304" rIns="146304" tIns="128016" bIns="128016"/>
-          <a:lstStyle/>
-          <a:p>
-            <a:pPr algn="ctr">
-              <a:defRPr sz="1050" b="1">
-                <a:solidFill>
-                  <a:srgbClr val="0F294D"/>
-                </a:solidFill>
-                <a:latin typeface="Times New Roman"/>
-              </a:defRPr>
-            </a:pPr>
-            <a:r>
-              <a:t>FASE 4: TRIAL RUN &amp; BUKA</a:t>
-            </a:r>
-          </a:p>
-          <a:p>
-            <a:pPr>
-              <a:defRPr sz="950" b="1">
-                <a:solidFill>
-                  <a:srgbClr val="475569"/>
-                </a:solidFill>
-                <a:latin typeface="Times New Roman"/>
-              </a:defRPr>
-            </a:pPr>
-            <a:r>
-              <a:t>Jadwal: Minggu 11 - 12</a:t>
-            </a:r>
-          </a:p>
-          <a:p>
-            <a:pPr>
-              <a:defRPr sz="900">
-                <a:solidFill>
-                  <a:srgbClr val="0F172A"/>
-                </a:solidFill>
-                <a:latin typeface="Times New Roman"/>
-              </a:defRPr>
-            </a:pPr>
-            <a:r>
-              <a:t>• M. Rekrutmen 3 karyawan tetap (Koki-Kasir)</a:t>
-            </a:r>
-          </a:p>
-          <a:p>
-            <a:pPr>
-              <a:defRPr sz="900">
-                <a:solidFill>
-                  <a:srgbClr val="0F172A"/>
-                </a:solidFill>
-                <a:latin typeface="Times New Roman"/>
-              </a:defRPr>
-            </a:pPr>
-            <a:r>
-              <a:t>• N. Pelatihan adonan mingguan &amp; kaldu 1999</a:t>
-            </a:r>
-          </a:p>
-          <a:p>
-            <a:pPr>
-              <a:defRPr sz="900">
-                <a:solidFill>
-                  <a:srgbClr val="0F172A"/>
-                </a:solidFill>
-                <a:latin typeface="Times New Roman"/>
-              </a:defRPr>
-            </a:pPr>
-            <a:r>
-              <a:t>• O. Simulasi alur santap dine-in &amp; nota manual</a:t>
-            </a:r>
-          </a:p>
-          <a:p>
-            <a:pPr>
-              <a:defRPr sz="900">
-                <a:solidFill>
-                  <a:srgbClr val="0F172A"/>
-                </a:solidFill>
-                <a:latin typeface="Times New Roman"/>
-              </a:defRPr>
-            </a:pPr>
-            <a:r>
-              <a:t>• P. Grand Opening resmi melayani warga Kosambi</a:t>
+              <a:t>Fase 1 (Mg 1-4: Survei &amp; Sewa Rp 20 Jt)  |  Fase 2 (Mg 5-8: Renovasi, 6 Kipas, Gerobak Teras)  |  Fase 3 (Mg 9-10: Alat &amp; 23 Kursi)  |  Fase 4 (Mg 11-12: Buka)</a:t>
             </a:r>
           </a:p>
         </p:txBody>

</xml_diff>